<commit_message>
Use a reusable settlement template with fifteen direct expense slots
</commit_message>
<xml_diff>
--- a/app/public/templates/settlement.pptx
+++ b/app/public/templates/settlement.pptx
@@ -12495,7 +12495,7 @@
         <p:nvGraphicFramePr>
           <p:cNvPr id="12" name="표 11">
             <a:extLst>
-              <a:ext uri="{FF2B5EF4-FFF2-40B4-BE49-F238E27FC236}">
+              <a:ext uri="{FF2B5EF4-FFF2-40B4-BE49-F238E27FC236}" cy="5671358">
                 <a16:creationId xmlns:a16="http://schemas.microsoft.com/office/drawing/2014/main" id="{D56C03BF-6BC9-B747-F58D-DCB9E1A4A73F}"/>
               </a:ext>
             </a:extLst>
@@ -12736,7 +12736,7 @@
                   </a:ext>
                 </a:extLst>
               </a:tr>
-              <a:tr h="377555">
+              <a:tr h="330000">
                 <a:tc>
                   <a:txBody>
                     <a:bodyPr/>
@@ -12755,7 +12755,7 @@
                           <a:ea typeface="Microsoft GothicNeo" panose="020B0500000101010101" pitchFamily="50" charset="-127"/>
                           <a:cs typeface="+mn-cs"/>
                         </a:rPr>
-                        <a:t>1 </a:t>
+                        <a:t>1</a:t>
                       </a:r>
                     </a:p>
                   </a:txBody>
@@ -12779,7 +12779,7 @@
                           <a:ea typeface="Microsoft GothicNeo" panose="020B0500000101010101" pitchFamily="50" charset="-127"/>
                           <a:cs typeface="+mn-cs"/>
                         </a:rPr>
-                        <a:t>직접성 경비</a:t>
+                        <a:t/>
                       </a:r>
                     </a:p>
                   </a:txBody>
@@ -12803,7 +12803,7 @@
                           <a:ea typeface="Microsoft GothicNeo" panose="020B0500000101010101" pitchFamily="50" charset="-127"/>
                           <a:cs typeface="+mn-cs"/>
                         </a:rPr>
-                        <a:t>26.11.02</a:t>
+                        <a:t/>
                       </a:r>
                       <a:endParaRPr lang="ko-KR" altLang="en-US" sz="900" b="0" i="0" u="none" strike="noStrike" kern="1200" dirty="0">
                         <a:solidFill>
@@ -12836,7 +12836,7 @@
                           <a:ea typeface="Microsoft GothicNeo" panose="020B0500000101010101" pitchFamily="50" charset="-127"/>
                           <a:cs typeface="+mn-cs"/>
                         </a:rPr>
-                        <a:t>세부 내역 기입</a:t>
+                        <a:t/>
                       </a:r>
                       <a:endParaRPr lang="en-US" altLang="ko-KR" sz="900" b="0" i="0" u="none" strike="noStrike" kern="1200" dirty="0">
                         <a:solidFill>
@@ -12869,7 +12869,7 @@
                           <a:ea typeface="Microsoft GothicNeo" panose="020B0500000101010101" pitchFamily="50" charset="-127"/>
                           <a:cs typeface="+mn-cs"/>
                         </a:rPr>
-                        <a:t>사용 금액 기입</a:t>
+                        <a:t/>
                       </a:r>
                       <a:endParaRPr lang="en-US" altLang="ko-KR" sz="900" b="0" i="0" u="none" strike="noStrike" kern="1200" dirty="0">
                         <a:solidFill>
@@ -12890,7 +12890,7 @@
                   </a:ext>
                 </a:extLst>
               </a:tr>
-              <a:tr h="377555">
+              <a:tr h="330000">
                 <a:tc>
                   <a:txBody>
                     <a:bodyPr/>
@@ -12909,7 +12909,7 @@
                           <a:ea typeface="Microsoft GothicNeo" panose="020B0500000101010101" pitchFamily="50" charset="-127"/>
                           <a:cs typeface="+mn-cs"/>
                         </a:rPr>
-                        <a:t>2 </a:t>
+                        <a:t>2</a:t>
                       </a:r>
                     </a:p>
                   </a:txBody>
@@ -12952,7 +12952,7 @@
                           <a:ea typeface="Microsoft GothicNeo" panose="020B0500000101010101" pitchFamily="50" charset="-127"/>
                           <a:cs typeface="+mn-cs"/>
                         </a:rPr>
-                        <a:t>직접성 경비</a:t>
+                        <a:t/>
                       </a:r>
                       <a:endParaRPr kumimoji="0" lang="ko-KR" altLang="en-US" sz="900" b="0" i="0" u="none" strike="noStrike" kern="1200" cap="none" spc="0" normalizeH="0" baseline="0" noProof="0" dirty="0">
                         <a:ln>
@@ -12990,7 +12990,7 @@
                           <a:ea typeface="Microsoft GothicNeo" panose="020B0500000101010101" pitchFamily="50" charset="-127"/>
                           <a:cs typeface="+mn-cs"/>
                         </a:rPr>
-                        <a:t>…</a:t>
+                        <a:t/>
                       </a:r>
                       <a:endParaRPr lang="ko-KR" altLang="en-US" sz="900" b="0" i="0" u="none" strike="noStrike" kern="1200" dirty="0">
                         <a:solidFill>
@@ -13023,7 +13023,7 @@
                           <a:ea typeface="Microsoft GothicNeo" panose="020B0500000101010101" pitchFamily="50" charset="-127"/>
                           <a:cs typeface="+mn-cs"/>
                         </a:rPr>
-                        <a:t>…</a:t>
+                        <a:t/>
                       </a:r>
                       <a:endParaRPr lang="ko-KR" altLang="en-US" sz="900" b="0" i="0" u="none" strike="noStrike" kern="1200" dirty="0">
                         <a:solidFill>
@@ -13056,7 +13056,7 @@
                           <a:ea typeface="Microsoft GothicNeo" panose="020B0500000101010101" pitchFamily="50" charset="-127"/>
                           <a:cs typeface="+mn-cs"/>
                         </a:rPr>
-                        <a:t>…</a:t>
+                        <a:t/>
                       </a:r>
                     </a:p>
                   </a:txBody>
@@ -13068,7 +13068,7 @@
                   </a:ext>
                 </a:extLst>
               </a:tr>
-              <a:tr h="377555">
+              <a:tr h="330000">
                 <a:tc>
                   <a:txBody>
                     <a:bodyPr/>
@@ -13130,7 +13130,7 @@
                           <a:ea typeface="Microsoft GothicNeo" panose="020B0500000101010101" pitchFamily="50" charset="-127"/>
                           <a:cs typeface="+mn-cs"/>
                         </a:rPr>
-                        <a:t>직접성 경비</a:t>
+                        <a:t/>
                       </a:r>
                     </a:p>
                   </a:txBody>
@@ -13154,7 +13154,7 @@
                           <a:ea typeface="Microsoft GothicNeo" panose="020B0500000101010101" pitchFamily="50" charset="-127"/>
                           <a:cs typeface="+mn-cs"/>
                         </a:rPr>
-                        <a:t>…</a:t>
+                        <a:t/>
                       </a:r>
                       <a:endParaRPr lang="ko-KR" altLang="en-US" sz="900" b="0" i="0" u="none" strike="noStrike" kern="1200" dirty="0">
                         <a:solidFill>
@@ -13187,7 +13187,7 @@
                           <a:ea typeface="Microsoft GothicNeo" panose="020B0500000101010101" pitchFamily="50" charset="-127"/>
                           <a:cs typeface="+mn-cs"/>
                         </a:rPr>
-                        <a:t>…</a:t>
+                        <a:t/>
                       </a:r>
                       <a:endParaRPr lang="ko-KR" altLang="en-US" sz="900" b="0" i="0" u="none" strike="noStrike" kern="1200" dirty="0">
                         <a:solidFill>
@@ -13220,7 +13220,7 @@
                           <a:ea typeface="Microsoft GothicNeo" panose="020B0500000101010101" pitchFamily="50" charset="-127"/>
                           <a:cs typeface="+mn-cs"/>
                         </a:rPr>
-                        <a:t>…</a:t>
+                        <a:t/>
                       </a:r>
                     </a:p>
                   </a:txBody>
@@ -13229,6 +13229,1854 @@
                 <a:extLst>
                   <a:ext uri="{0D108BD9-81ED-4DB2-BD59-A6C34878D82A}">
                     <a16:rowId xmlns:a16="http://schemas.microsoft.com/office/drawing/2014/main" val="3029183094"/>
+                  </a:ext>
+                </a:extLst>
+              </a:tr>
+              <a:tr h="330000">
+                <a:tc>
+                  <a:txBody>
+                    <a:bodyPr/>
+                    <a:lstStyle/>
+                    <a:p>
+                      <a:pPr algn="ctr" fontAlgn="ctr">
+                        <a:buNone/>
+                      </a:pPr>
+                      <a:r>
+                        <a:rPr lang="en-US" altLang="ko-KR" sz="900" b="0" i="0" u="none" strike="noStrike" kern="1200">
+                          <a:solidFill>
+                            <a:srgbClr val="000000"/>
+                          </a:solidFill>
+                          <a:effectLst/>
+                          <a:latin typeface="Microsoft GothicNeo" panose="020B0500000101010101" pitchFamily="50" charset="-127"/>
+                          <a:ea typeface="Microsoft GothicNeo" panose="020B0500000101010101" pitchFamily="50" charset="-127"/>
+                          <a:cs typeface="+mn-cs"/>
+                        </a:rPr>
+                        <a:t>4</a:t>
+                      </a:r>
+                    </a:p>
+                  </a:txBody>
+                  <a:tcPr marL="5721" marR="5721" marT="5721" marB="0" anchor="ctr"/>
+                </a:tc>
+                <a:tc>
+                  <a:txBody>
+                    <a:bodyPr/>
+                    <a:lstStyle/>
+                    <a:p>
+                      <a:pPr algn="ctr" fontAlgn="ctr">
+                        <a:buNone/>
+                      </a:pPr>
+                      <a:r>
+                        <a:rPr lang="ko-KR" altLang="en-US" sz="900" b="0" i="0" u="none" strike="noStrike" kern="1200" dirty="0">
+                          <a:solidFill>
+                            <a:srgbClr val="000000"/>
+                          </a:solidFill>
+                          <a:effectLst/>
+                          <a:latin typeface="Microsoft GothicNeo" panose="020B0500000101010101" pitchFamily="50" charset="-127"/>
+                          <a:ea typeface="Microsoft GothicNeo" panose="020B0500000101010101" pitchFamily="50" charset="-127"/>
+                          <a:cs typeface="+mn-cs"/>
+                        </a:rPr>
+                        <a:t/>
+                      </a:r>
+                    </a:p>
+                  </a:txBody>
+                  <a:tcPr marL="5721" marR="5721" marT="5721" marB="0" anchor="ctr"/>
+                </a:tc>
+                <a:tc>
+                  <a:txBody>
+                    <a:bodyPr/>
+                    <a:lstStyle/>
+                    <a:p>
+                      <a:pPr algn="ctr" fontAlgn="ctr">
+                        <a:buNone/>
+                      </a:pPr>
+                      <a:r>
+                        <a:rPr lang="en-US" altLang="ko-KR" sz="900" b="0" i="0" u="none" strike="noStrike" kern="1200" dirty="0">
+                          <a:solidFill>
+                            <a:srgbClr val="0000FF"/>
+                          </a:solidFill>
+                          <a:effectLst/>
+                          <a:latin typeface="Microsoft GothicNeo" panose="020B0500000101010101" pitchFamily="50" charset="-127"/>
+                          <a:ea typeface="Microsoft GothicNeo" panose="020B0500000101010101" pitchFamily="50" charset="-127"/>
+                          <a:cs typeface="+mn-cs"/>
+                        </a:rPr>
+                        <a:t/>
+                      </a:r>
+                      <a:endParaRPr lang="ko-KR" altLang="en-US" sz="900" b="0" i="0" u="none" strike="noStrike" kern="1200" dirty="0">
+                        <a:solidFill>
+                          <a:srgbClr val="0000FF"/>
+                        </a:solidFill>
+                        <a:effectLst/>
+                        <a:latin typeface="Microsoft GothicNeo" panose="020B0500000101010101" pitchFamily="50" charset="-127"/>
+                        <a:ea typeface="Microsoft GothicNeo" panose="020B0500000101010101" pitchFamily="50" charset="-127"/>
+                        <a:cs typeface="+mn-cs"/>
+                      </a:endParaRPr>
+                    </a:p>
+                  </a:txBody>
+                  <a:tcPr marL="5721" marR="5721" marT="5721" marB="0" anchor="ctr"/>
+                </a:tc>
+                <a:tc>
+                  <a:txBody>
+                    <a:bodyPr/>
+                    <a:lstStyle/>
+                    <a:p>
+                      <a:pPr algn="ctr" fontAlgn="ctr">
+                        <a:buNone/>
+                      </a:pPr>
+                      <a:r>
+                        <a:rPr lang="ko-KR" altLang="en-US" sz="900" b="0" i="0" u="none" strike="noStrike" kern="1200" dirty="0">
+                          <a:solidFill>
+                            <a:srgbClr val="0000FF"/>
+                          </a:solidFill>
+                          <a:effectLst/>
+                          <a:latin typeface="Microsoft GothicNeo" panose="020B0500000101010101" pitchFamily="50" charset="-127"/>
+                          <a:ea typeface="Microsoft GothicNeo" panose="020B0500000101010101" pitchFamily="50" charset="-127"/>
+                          <a:cs typeface="+mn-cs"/>
+                        </a:rPr>
+                        <a:t/>
+                      </a:r>
+                      <a:endParaRPr lang="en-US" altLang="ko-KR" sz="900" b="0" i="0" u="none" strike="noStrike" kern="1200" dirty="0">
+                        <a:solidFill>
+                          <a:srgbClr val="0000FF"/>
+                        </a:solidFill>
+                        <a:effectLst/>
+                        <a:latin typeface="Microsoft GothicNeo" panose="020B0500000101010101" pitchFamily="50" charset="-127"/>
+                        <a:ea typeface="Microsoft GothicNeo" panose="020B0500000101010101" pitchFamily="50" charset="-127"/>
+                        <a:cs typeface="+mn-cs"/>
+                      </a:endParaRPr>
+                    </a:p>
+                  </a:txBody>
+                  <a:tcPr marL="5721" marR="5721" marT="5721" marB="0" anchor="ctr"/>
+                </a:tc>
+                <a:tc>
+                  <a:txBody>
+                    <a:bodyPr/>
+                    <a:lstStyle/>
+                    <a:p>
+                      <a:pPr algn="r" fontAlgn="ctr">
+                        <a:buNone/>
+                      </a:pPr>
+                      <a:r>
+                        <a:rPr lang="ko-KR" altLang="en-US" sz="900" b="0" i="0" u="none" strike="noStrike" kern="1200" dirty="0">
+                          <a:solidFill>
+                            <a:srgbClr val="0000FF"/>
+                          </a:solidFill>
+                          <a:effectLst/>
+                          <a:latin typeface="Microsoft GothicNeo" panose="020B0500000101010101" pitchFamily="50" charset="-127"/>
+                          <a:ea typeface="Microsoft GothicNeo" panose="020B0500000101010101" pitchFamily="50" charset="-127"/>
+                          <a:cs typeface="+mn-cs"/>
+                        </a:rPr>
+                        <a:t/>
+                      </a:r>
+                      <a:endParaRPr lang="en-US" altLang="ko-KR" sz="900" b="0" i="0" u="none" strike="noStrike" kern="1200" dirty="0">
+                        <a:solidFill>
+                          <a:srgbClr val="0000FF"/>
+                        </a:solidFill>
+                        <a:effectLst/>
+                        <a:latin typeface="Microsoft GothicNeo" panose="020B0500000101010101" pitchFamily="50" charset="-127"/>
+                        <a:ea typeface="Microsoft GothicNeo" panose="020B0500000101010101" pitchFamily="50" charset="-127"/>
+                        <a:cs typeface="+mn-cs"/>
+                      </a:endParaRPr>
+                    </a:p>
+                  </a:txBody>
+                  <a:tcPr marL="5721" marR="5721" marT="5721" marB="0" anchor="ctr"/>
+                </a:tc>
+                <a:extLst>
+                  <a:ext uri="{0D108BD9-81ED-4DB2-BD59-A6C34878D82A}">
+                    <a16:rowId xmlns:a16="http://schemas.microsoft.com/office/drawing/2014/main" val="3639418345"/>
+                  </a:ext>
+                </a:extLst>
+              </a:tr>
+              <a:tr h="330000">
+                <a:tc>
+                  <a:txBody>
+                    <a:bodyPr/>
+                    <a:lstStyle/>
+                    <a:p>
+                      <a:pPr algn="ctr" fontAlgn="ctr">
+                        <a:buNone/>
+                      </a:pPr>
+                      <a:r>
+                        <a:rPr lang="en-US" altLang="ko-KR" sz="900" b="0" i="0" u="none" strike="noStrike" kern="1200">
+                          <a:solidFill>
+                            <a:srgbClr val="000000"/>
+                          </a:solidFill>
+                          <a:effectLst/>
+                          <a:latin typeface="Microsoft GothicNeo" panose="020B0500000101010101" pitchFamily="50" charset="-127"/>
+                          <a:ea typeface="Microsoft GothicNeo" panose="020B0500000101010101" pitchFamily="50" charset="-127"/>
+                          <a:cs typeface="+mn-cs"/>
+                        </a:rPr>
+                        <a:t>5</a:t>
+                      </a:r>
+                    </a:p>
+                  </a:txBody>
+                  <a:tcPr marL="5721" marR="5721" marT="5721" marB="0" anchor="ctr"/>
+                </a:tc>
+                <a:tc>
+                  <a:txBody>
+                    <a:bodyPr/>
+                    <a:lstStyle/>
+                    <a:p>
+                      <a:pPr algn="ctr" fontAlgn="ctr">
+                        <a:buNone/>
+                      </a:pPr>
+                      <a:r>
+                        <a:rPr lang="ko-KR" altLang="en-US" sz="900" b="0" i="0" u="none" strike="noStrike" kern="1200" dirty="0">
+                          <a:solidFill>
+                            <a:srgbClr val="000000"/>
+                          </a:solidFill>
+                          <a:effectLst/>
+                          <a:latin typeface="Microsoft GothicNeo" panose="020B0500000101010101" pitchFamily="50" charset="-127"/>
+                          <a:ea typeface="Microsoft GothicNeo" panose="020B0500000101010101" pitchFamily="50" charset="-127"/>
+                          <a:cs typeface="+mn-cs"/>
+                        </a:rPr>
+                        <a:t/>
+                      </a:r>
+                    </a:p>
+                  </a:txBody>
+                  <a:tcPr marL="5721" marR="5721" marT="5721" marB="0" anchor="ctr"/>
+                </a:tc>
+                <a:tc>
+                  <a:txBody>
+                    <a:bodyPr/>
+                    <a:lstStyle/>
+                    <a:p>
+                      <a:pPr algn="ctr" fontAlgn="ctr">
+                        <a:buNone/>
+                      </a:pPr>
+                      <a:r>
+                        <a:rPr lang="en-US" altLang="ko-KR" sz="900" b="0" i="0" u="none" strike="noStrike" kern="1200" dirty="0">
+                          <a:solidFill>
+                            <a:srgbClr val="0000FF"/>
+                          </a:solidFill>
+                          <a:effectLst/>
+                          <a:latin typeface="Microsoft GothicNeo" panose="020B0500000101010101" pitchFamily="50" charset="-127"/>
+                          <a:ea typeface="Microsoft GothicNeo" panose="020B0500000101010101" pitchFamily="50" charset="-127"/>
+                          <a:cs typeface="+mn-cs"/>
+                        </a:rPr>
+                        <a:t/>
+                      </a:r>
+                      <a:endParaRPr lang="ko-KR" altLang="en-US" sz="900" b="0" i="0" u="none" strike="noStrike" kern="1200" dirty="0">
+                        <a:solidFill>
+                          <a:srgbClr val="0000FF"/>
+                        </a:solidFill>
+                        <a:effectLst/>
+                        <a:latin typeface="Microsoft GothicNeo" panose="020B0500000101010101" pitchFamily="50" charset="-127"/>
+                        <a:ea typeface="Microsoft GothicNeo" panose="020B0500000101010101" pitchFamily="50" charset="-127"/>
+                        <a:cs typeface="+mn-cs"/>
+                      </a:endParaRPr>
+                    </a:p>
+                  </a:txBody>
+                  <a:tcPr marL="5721" marR="5721" marT="5721" marB="0" anchor="ctr"/>
+                </a:tc>
+                <a:tc>
+                  <a:txBody>
+                    <a:bodyPr/>
+                    <a:lstStyle/>
+                    <a:p>
+                      <a:pPr algn="ctr" fontAlgn="ctr">
+                        <a:buNone/>
+                      </a:pPr>
+                      <a:r>
+                        <a:rPr lang="ko-KR" altLang="en-US" sz="900" b="0" i="0" u="none" strike="noStrike" kern="1200" dirty="0">
+                          <a:solidFill>
+                            <a:srgbClr val="0000FF"/>
+                          </a:solidFill>
+                          <a:effectLst/>
+                          <a:latin typeface="Microsoft GothicNeo" panose="020B0500000101010101" pitchFamily="50" charset="-127"/>
+                          <a:ea typeface="Microsoft GothicNeo" panose="020B0500000101010101" pitchFamily="50" charset="-127"/>
+                          <a:cs typeface="+mn-cs"/>
+                        </a:rPr>
+                        <a:t/>
+                      </a:r>
+                      <a:endParaRPr lang="en-US" altLang="ko-KR" sz="900" b="0" i="0" u="none" strike="noStrike" kern="1200" dirty="0">
+                        <a:solidFill>
+                          <a:srgbClr val="0000FF"/>
+                        </a:solidFill>
+                        <a:effectLst/>
+                        <a:latin typeface="Microsoft GothicNeo" panose="020B0500000101010101" pitchFamily="50" charset="-127"/>
+                        <a:ea typeface="Microsoft GothicNeo" panose="020B0500000101010101" pitchFamily="50" charset="-127"/>
+                        <a:cs typeface="+mn-cs"/>
+                      </a:endParaRPr>
+                    </a:p>
+                  </a:txBody>
+                  <a:tcPr marL="5721" marR="5721" marT="5721" marB="0" anchor="ctr"/>
+                </a:tc>
+                <a:tc>
+                  <a:txBody>
+                    <a:bodyPr/>
+                    <a:lstStyle/>
+                    <a:p>
+                      <a:pPr algn="r" fontAlgn="ctr">
+                        <a:buNone/>
+                      </a:pPr>
+                      <a:r>
+                        <a:rPr lang="ko-KR" altLang="en-US" sz="900" b="0" i="0" u="none" strike="noStrike" kern="1200" dirty="0">
+                          <a:solidFill>
+                            <a:srgbClr val="0000FF"/>
+                          </a:solidFill>
+                          <a:effectLst/>
+                          <a:latin typeface="Microsoft GothicNeo" panose="020B0500000101010101" pitchFamily="50" charset="-127"/>
+                          <a:ea typeface="Microsoft GothicNeo" panose="020B0500000101010101" pitchFamily="50" charset="-127"/>
+                          <a:cs typeface="+mn-cs"/>
+                        </a:rPr>
+                        <a:t/>
+                      </a:r>
+                      <a:endParaRPr lang="en-US" altLang="ko-KR" sz="900" b="0" i="0" u="none" strike="noStrike" kern="1200" dirty="0">
+                        <a:solidFill>
+                          <a:srgbClr val="0000FF"/>
+                        </a:solidFill>
+                        <a:effectLst/>
+                        <a:latin typeface="Microsoft GothicNeo" panose="020B0500000101010101" pitchFamily="50" charset="-127"/>
+                        <a:ea typeface="Microsoft GothicNeo" panose="020B0500000101010101" pitchFamily="50" charset="-127"/>
+                        <a:cs typeface="+mn-cs"/>
+                      </a:endParaRPr>
+                    </a:p>
+                  </a:txBody>
+                  <a:tcPr marL="5721" marR="5721" marT="5721" marB="0" anchor="ctr"/>
+                </a:tc>
+                <a:extLst>
+                  <a:ext uri="{0D108BD9-81ED-4DB2-BD59-A6C34878D82A}">
+                    <a16:rowId xmlns:a16="http://schemas.microsoft.com/office/drawing/2014/main" val="3639418345"/>
+                  </a:ext>
+                </a:extLst>
+              </a:tr>
+              <a:tr h="330000">
+                <a:tc>
+                  <a:txBody>
+                    <a:bodyPr/>
+                    <a:lstStyle/>
+                    <a:p>
+                      <a:pPr algn="ctr" fontAlgn="ctr">
+                        <a:buNone/>
+                      </a:pPr>
+                      <a:r>
+                        <a:rPr lang="en-US" altLang="ko-KR" sz="900" b="0" i="0" u="none" strike="noStrike" kern="1200">
+                          <a:solidFill>
+                            <a:srgbClr val="000000"/>
+                          </a:solidFill>
+                          <a:effectLst/>
+                          <a:latin typeface="Microsoft GothicNeo" panose="020B0500000101010101" pitchFamily="50" charset="-127"/>
+                          <a:ea typeface="Microsoft GothicNeo" panose="020B0500000101010101" pitchFamily="50" charset="-127"/>
+                          <a:cs typeface="+mn-cs"/>
+                        </a:rPr>
+                        <a:t>6</a:t>
+                      </a:r>
+                    </a:p>
+                  </a:txBody>
+                  <a:tcPr marL="5721" marR="5721" marT="5721" marB="0" anchor="ctr"/>
+                </a:tc>
+                <a:tc>
+                  <a:txBody>
+                    <a:bodyPr/>
+                    <a:lstStyle/>
+                    <a:p>
+                      <a:pPr algn="ctr" fontAlgn="ctr">
+                        <a:buNone/>
+                      </a:pPr>
+                      <a:r>
+                        <a:rPr lang="ko-KR" altLang="en-US" sz="900" b="0" i="0" u="none" strike="noStrike" kern="1200" dirty="0">
+                          <a:solidFill>
+                            <a:srgbClr val="000000"/>
+                          </a:solidFill>
+                          <a:effectLst/>
+                          <a:latin typeface="Microsoft GothicNeo" panose="020B0500000101010101" pitchFamily="50" charset="-127"/>
+                          <a:ea typeface="Microsoft GothicNeo" panose="020B0500000101010101" pitchFamily="50" charset="-127"/>
+                          <a:cs typeface="+mn-cs"/>
+                        </a:rPr>
+                        <a:t/>
+                      </a:r>
+                    </a:p>
+                  </a:txBody>
+                  <a:tcPr marL="5721" marR="5721" marT="5721" marB="0" anchor="ctr"/>
+                </a:tc>
+                <a:tc>
+                  <a:txBody>
+                    <a:bodyPr/>
+                    <a:lstStyle/>
+                    <a:p>
+                      <a:pPr algn="ctr" fontAlgn="ctr">
+                        <a:buNone/>
+                      </a:pPr>
+                      <a:r>
+                        <a:rPr lang="en-US" altLang="ko-KR" sz="900" b="0" i="0" u="none" strike="noStrike" kern="1200" dirty="0">
+                          <a:solidFill>
+                            <a:srgbClr val="0000FF"/>
+                          </a:solidFill>
+                          <a:effectLst/>
+                          <a:latin typeface="Microsoft GothicNeo" panose="020B0500000101010101" pitchFamily="50" charset="-127"/>
+                          <a:ea typeface="Microsoft GothicNeo" panose="020B0500000101010101" pitchFamily="50" charset="-127"/>
+                          <a:cs typeface="+mn-cs"/>
+                        </a:rPr>
+                        <a:t/>
+                      </a:r>
+                      <a:endParaRPr lang="ko-KR" altLang="en-US" sz="900" b="0" i="0" u="none" strike="noStrike" kern="1200" dirty="0">
+                        <a:solidFill>
+                          <a:srgbClr val="0000FF"/>
+                        </a:solidFill>
+                        <a:effectLst/>
+                        <a:latin typeface="Microsoft GothicNeo" panose="020B0500000101010101" pitchFamily="50" charset="-127"/>
+                        <a:ea typeface="Microsoft GothicNeo" panose="020B0500000101010101" pitchFamily="50" charset="-127"/>
+                        <a:cs typeface="+mn-cs"/>
+                      </a:endParaRPr>
+                    </a:p>
+                  </a:txBody>
+                  <a:tcPr marL="5721" marR="5721" marT="5721" marB="0" anchor="ctr"/>
+                </a:tc>
+                <a:tc>
+                  <a:txBody>
+                    <a:bodyPr/>
+                    <a:lstStyle/>
+                    <a:p>
+                      <a:pPr algn="ctr" fontAlgn="ctr">
+                        <a:buNone/>
+                      </a:pPr>
+                      <a:r>
+                        <a:rPr lang="ko-KR" altLang="en-US" sz="900" b="0" i="0" u="none" strike="noStrike" kern="1200" dirty="0">
+                          <a:solidFill>
+                            <a:srgbClr val="0000FF"/>
+                          </a:solidFill>
+                          <a:effectLst/>
+                          <a:latin typeface="Microsoft GothicNeo" panose="020B0500000101010101" pitchFamily="50" charset="-127"/>
+                          <a:ea typeface="Microsoft GothicNeo" panose="020B0500000101010101" pitchFamily="50" charset="-127"/>
+                          <a:cs typeface="+mn-cs"/>
+                        </a:rPr>
+                        <a:t/>
+                      </a:r>
+                      <a:endParaRPr lang="en-US" altLang="ko-KR" sz="900" b="0" i="0" u="none" strike="noStrike" kern="1200" dirty="0">
+                        <a:solidFill>
+                          <a:srgbClr val="0000FF"/>
+                        </a:solidFill>
+                        <a:effectLst/>
+                        <a:latin typeface="Microsoft GothicNeo" panose="020B0500000101010101" pitchFamily="50" charset="-127"/>
+                        <a:ea typeface="Microsoft GothicNeo" panose="020B0500000101010101" pitchFamily="50" charset="-127"/>
+                        <a:cs typeface="+mn-cs"/>
+                      </a:endParaRPr>
+                    </a:p>
+                  </a:txBody>
+                  <a:tcPr marL="5721" marR="5721" marT="5721" marB="0" anchor="ctr"/>
+                </a:tc>
+                <a:tc>
+                  <a:txBody>
+                    <a:bodyPr/>
+                    <a:lstStyle/>
+                    <a:p>
+                      <a:pPr algn="r" fontAlgn="ctr">
+                        <a:buNone/>
+                      </a:pPr>
+                      <a:r>
+                        <a:rPr lang="ko-KR" altLang="en-US" sz="900" b="0" i="0" u="none" strike="noStrike" kern="1200" dirty="0">
+                          <a:solidFill>
+                            <a:srgbClr val="0000FF"/>
+                          </a:solidFill>
+                          <a:effectLst/>
+                          <a:latin typeface="Microsoft GothicNeo" panose="020B0500000101010101" pitchFamily="50" charset="-127"/>
+                          <a:ea typeface="Microsoft GothicNeo" panose="020B0500000101010101" pitchFamily="50" charset="-127"/>
+                          <a:cs typeface="+mn-cs"/>
+                        </a:rPr>
+                        <a:t/>
+                      </a:r>
+                      <a:endParaRPr lang="en-US" altLang="ko-KR" sz="900" b="0" i="0" u="none" strike="noStrike" kern="1200" dirty="0">
+                        <a:solidFill>
+                          <a:srgbClr val="0000FF"/>
+                        </a:solidFill>
+                        <a:effectLst/>
+                        <a:latin typeface="Microsoft GothicNeo" panose="020B0500000101010101" pitchFamily="50" charset="-127"/>
+                        <a:ea typeface="Microsoft GothicNeo" panose="020B0500000101010101" pitchFamily="50" charset="-127"/>
+                        <a:cs typeface="+mn-cs"/>
+                      </a:endParaRPr>
+                    </a:p>
+                  </a:txBody>
+                  <a:tcPr marL="5721" marR="5721" marT="5721" marB="0" anchor="ctr"/>
+                </a:tc>
+                <a:extLst>
+                  <a:ext uri="{0D108BD9-81ED-4DB2-BD59-A6C34878D82A}">
+                    <a16:rowId xmlns:a16="http://schemas.microsoft.com/office/drawing/2014/main" val="3639418345"/>
+                  </a:ext>
+                </a:extLst>
+              </a:tr>
+              <a:tr h="330000">
+                <a:tc>
+                  <a:txBody>
+                    <a:bodyPr/>
+                    <a:lstStyle/>
+                    <a:p>
+                      <a:pPr algn="ctr" fontAlgn="ctr">
+                        <a:buNone/>
+                      </a:pPr>
+                      <a:r>
+                        <a:rPr lang="en-US" altLang="ko-KR" sz="900" b="0" i="0" u="none" strike="noStrike" kern="1200">
+                          <a:solidFill>
+                            <a:srgbClr val="000000"/>
+                          </a:solidFill>
+                          <a:effectLst/>
+                          <a:latin typeface="Microsoft GothicNeo" panose="020B0500000101010101" pitchFamily="50" charset="-127"/>
+                          <a:ea typeface="Microsoft GothicNeo" panose="020B0500000101010101" pitchFamily="50" charset="-127"/>
+                          <a:cs typeface="+mn-cs"/>
+                        </a:rPr>
+                        <a:t>7</a:t>
+                      </a:r>
+                    </a:p>
+                  </a:txBody>
+                  <a:tcPr marL="5721" marR="5721" marT="5721" marB="0" anchor="ctr"/>
+                </a:tc>
+                <a:tc>
+                  <a:txBody>
+                    <a:bodyPr/>
+                    <a:lstStyle/>
+                    <a:p>
+                      <a:pPr algn="ctr" fontAlgn="ctr">
+                        <a:buNone/>
+                      </a:pPr>
+                      <a:r>
+                        <a:rPr lang="ko-KR" altLang="en-US" sz="900" b="0" i="0" u="none" strike="noStrike" kern="1200" dirty="0">
+                          <a:solidFill>
+                            <a:srgbClr val="000000"/>
+                          </a:solidFill>
+                          <a:effectLst/>
+                          <a:latin typeface="Microsoft GothicNeo" panose="020B0500000101010101" pitchFamily="50" charset="-127"/>
+                          <a:ea typeface="Microsoft GothicNeo" panose="020B0500000101010101" pitchFamily="50" charset="-127"/>
+                          <a:cs typeface="+mn-cs"/>
+                        </a:rPr>
+                        <a:t/>
+                      </a:r>
+                    </a:p>
+                  </a:txBody>
+                  <a:tcPr marL="5721" marR="5721" marT="5721" marB="0" anchor="ctr"/>
+                </a:tc>
+                <a:tc>
+                  <a:txBody>
+                    <a:bodyPr/>
+                    <a:lstStyle/>
+                    <a:p>
+                      <a:pPr algn="ctr" fontAlgn="ctr">
+                        <a:buNone/>
+                      </a:pPr>
+                      <a:r>
+                        <a:rPr lang="en-US" altLang="ko-KR" sz="900" b="0" i="0" u="none" strike="noStrike" kern="1200" dirty="0">
+                          <a:solidFill>
+                            <a:srgbClr val="0000FF"/>
+                          </a:solidFill>
+                          <a:effectLst/>
+                          <a:latin typeface="Microsoft GothicNeo" panose="020B0500000101010101" pitchFamily="50" charset="-127"/>
+                          <a:ea typeface="Microsoft GothicNeo" panose="020B0500000101010101" pitchFamily="50" charset="-127"/>
+                          <a:cs typeface="+mn-cs"/>
+                        </a:rPr>
+                        <a:t/>
+                      </a:r>
+                      <a:endParaRPr lang="ko-KR" altLang="en-US" sz="900" b="0" i="0" u="none" strike="noStrike" kern="1200" dirty="0">
+                        <a:solidFill>
+                          <a:srgbClr val="0000FF"/>
+                        </a:solidFill>
+                        <a:effectLst/>
+                        <a:latin typeface="Microsoft GothicNeo" panose="020B0500000101010101" pitchFamily="50" charset="-127"/>
+                        <a:ea typeface="Microsoft GothicNeo" panose="020B0500000101010101" pitchFamily="50" charset="-127"/>
+                        <a:cs typeface="+mn-cs"/>
+                      </a:endParaRPr>
+                    </a:p>
+                  </a:txBody>
+                  <a:tcPr marL="5721" marR="5721" marT="5721" marB="0" anchor="ctr"/>
+                </a:tc>
+                <a:tc>
+                  <a:txBody>
+                    <a:bodyPr/>
+                    <a:lstStyle/>
+                    <a:p>
+                      <a:pPr algn="ctr" fontAlgn="ctr">
+                        <a:buNone/>
+                      </a:pPr>
+                      <a:r>
+                        <a:rPr lang="ko-KR" altLang="en-US" sz="900" b="0" i="0" u="none" strike="noStrike" kern="1200" dirty="0">
+                          <a:solidFill>
+                            <a:srgbClr val="0000FF"/>
+                          </a:solidFill>
+                          <a:effectLst/>
+                          <a:latin typeface="Microsoft GothicNeo" panose="020B0500000101010101" pitchFamily="50" charset="-127"/>
+                          <a:ea typeface="Microsoft GothicNeo" panose="020B0500000101010101" pitchFamily="50" charset="-127"/>
+                          <a:cs typeface="+mn-cs"/>
+                        </a:rPr>
+                        <a:t/>
+                      </a:r>
+                      <a:endParaRPr lang="en-US" altLang="ko-KR" sz="900" b="0" i="0" u="none" strike="noStrike" kern="1200" dirty="0">
+                        <a:solidFill>
+                          <a:srgbClr val="0000FF"/>
+                        </a:solidFill>
+                        <a:effectLst/>
+                        <a:latin typeface="Microsoft GothicNeo" panose="020B0500000101010101" pitchFamily="50" charset="-127"/>
+                        <a:ea typeface="Microsoft GothicNeo" panose="020B0500000101010101" pitchFamily="50" charset="-127"/>
+                        <a:cs typeface="+mn-cs"/>
+                      </a:endParaRPr>
+                    </a:p>
+                  </a:txBody>
+                  <a:tcPr marL="5721" marR="5721" marT="5721" marB="0" anchor="ctr"/>
+                </a:tc>
+                <a:tc>
+                  <a:txBody>
+                    <a:bodyPr/>
+                    <a:lstStyle/>
+                    <a:p>
+                      <a:pPr algn="r" fontAlgn="ctr">
+                        <a:buNone/>
+                      </a:pPr>
+                      <a:r>
+                        <a:rPr lang="ko-KR" altLang="en-US" sz="900" b="0" i="0" u="none" strike="noStrike" kern="1200" dirty="0">
+                          <a:solidFill>
+                            <a:srgbClr val="0000FF"/>
+                          </a:solidFill>
+                          <a:effectLst/>
+                          <a:latin typeface="Microsoft GothicNeo" panose="020B0500000101010101" pitchFamily="50" charset="-127"/>
+                          <a:ea typeface="Microsoft GothicNeo" panose="020B0500000101010101" pitchFamily="50" charset="-127"/>
+                          <a:cs typeface="+mn-cs"/>
+                        </a:rPr>
+                        <a:t/>
+                      </a:r>
+                      <a:endParaRPr lang="en-US" altLang="ko-KR" sz="900" b="0" i="0" u="none" strike="noStrike" kern="1200" dirty="0">
+                        <a:solidFill>
+                          <a:srgbClr val="0000FF"/>
+                        </a:solidFill>
+                        <a:effectLst/>
+                        <a:latin typeface="Microsoft GothicNeo" panose="020B0500000101010101" pitchFamily="50" charset="-127"/>
+                        <a:ea typeface="Microsoft GothicNeo" panose="020B0500000101010101" pitchFamily="50" charset="-127"/>
+                        <a:cs typeface="+mn-cs"/>
+                      </a:endParaRPr>
+                    </a:p>
+                  </a:txBody>
+                  <a:tcPr marL="5721" marR="5721" marT="5721" marB="0" anchor="ctr"/>
+                </a:tc>
+                <a:extLst>
+                  <a:ext uri="{0D108BD9-81ED-4DB2-BD59-A6C34878D82A}">
+                    <a16:rowId xmlns:a16="http://schemas.microsoft.com/office/drawing/2014/main" val="3639418345"/>
+                  </a:ext>
+                </a:extLst>
+              </a:tr>
+              <a:tr h="330000">
+                <a:tc>
+                  <a:txBody>
+                    <a:bodyPr/>
+                    <a:lstStyle/>
+                    <a:p>
+                      <a:pPr algn="ctr" fontAlgn="ctr">
+                        <a:buNone/>
+                      </a:pPr>
+                      <a:r>
+                        <a:rPr lang="en-US" altLang="ko-KR" sz="900" b="0" i="0" u="none" strike="noStrike" kern="1200">
+                          <a:solidFill>
+                            <a:srgbClr val="000000"/>
+                          </a:solidFill>
+                          <a:effectLst/>
+                          <a:latin typeface="Microsoft GothicNeo" panose="020B0500000101010101" pitchFamily="50" charset="-127"/>
+                          <a:ea typeface="Microsoft GothicNeo" panose="020B0500000101010101" pitchFamily="50" charset="-127"/>
+                          <a:cs typeface="+mn-cs"/>
+                        </a:rPr>
+                        <a:t>8</a:t>
+                      </a:r>
+                    </a:p>
+                  </a:txBody>
+                  <a:tcPr marL="5721" marR="5721" marT="5721" marB="0" anchor="ctr"/>
+                </a:tc>
+                <a:tc>
+                  <a:txBody>
+                    <a:bodyPr/>
+                    <a:lstStyle/>
+                    <a:p>
+                      <a:pPr algn="ctr" fontAlgn="ctr">
+                        <a:buNone/>
+                      </a:pPr>
+                      <a:r>
+                        <a:rPr lang="ko-KR" altLang="en-US" sz="900" b="0" i="0" u="none" strike="noStrike" kern="1200" dirty="0">
+                          <a:solidFill>
+                            <a:srgbClr val="000000"/>
+                          </a:solidFill>
+                          <a:effectLst/>
+                          <a:latin typeface="Microsoft GothicNeo" panose="020B0500000101010101" pitchFamily="50" charset="-127"/>
+                          <a:ea typeface="Microsoft GothicNeo" panose="020B0500000101010101" pitchFamily="50" charset="-127"/>
+                          <a:cs typeface="+mn-cs"/>
+                        </a:rPr>
+                        <a:t/>
+                      </a:r>
+                    </a:p>
+                  </a:txBody>
+                  <a:tcPr marL="5721" marR="5721" marT="5721" marB="0" anchor="ctr"/>
+                </a:tc>
+                <a:tc>
+                  <a:txBody>
+                    <a:bodyPr/>
+                    <a:lstStyle/>
+                    <a:p>
+                      <a:pPr algn="ctr" fontAlgn="ctr">
+                        <a:buNone/>
+                      </a:pPr>
+                      <a:r>
+                        <a:rPr lang="en-US" altLang="ko-KR" sz="900" b="0" i="0" u="none" strike="noStrike" kern="1200" dirty="0">
+                          <a:solidFill>
+                            <a:srgbClr val="0000FF"/>
+                          </a:solidFill>
+                          <a:effectLst/>
+                          <a:latin typeface="Microsoft GothicNeo" panose="020B0500000101010101" pitchFamily="50" charset="-127"/>
+                          <a:ea typeface="Microsoft GothicNeo" panose="020B0500000101010101" pitchFamily="50" charset="-127"/>
+                          <a:cs typeface="+mn-cs"/>
+                        </a:rPr>
+                        <a:t/>
+                      </a:r>
+                      <a:endParaRPr lang="ko-KR" altLang="en-US" sz="900" b="0" i="0" u="none" strike="noStrike" kern="1200" dirty="0">
+                        <a:solidFill>
+                          <a:srgbClr val="0000FF"/>
+                        </a:solidFill>
+                        <a:effectLst/>
+                        <a:latin typeface="Microsoft GothicNeo" panose="020B0500000101010101" pitchFamily="50" charset="-127"/>
+                        <a:ea typeface="Microsoft GothicNeo" panose="020B0500000101010101" pitchFamily="50" charset="-127"/>
+                        <a:cs typeface="+mn-cs"/>
+                      </a:endParaRPr>
+                    </a:p>
+                  </a:txBody>
+                  <a:tcPr marL="5721" marR="5721" marT="5721" marB="0" anchor="ctr"/>
+                </a:tc>
+                <a:tc>
+                  <a:txBody>
+                    <a:bodyPr/>
+                    <a:lstStyle/>
+                    <a:p>
+                      <a:pPr algn="ctr" fontAlgn="ctr">
+                        <a:buNone/>
+                      </a:pPr>
+                      <a:r>
+                        <a:rPr lang="ko-KR" altLang="en-US" sz="900" b="0" i="0" u="none" strike="noStrike" kern="1200" dirty="0">
+                          <a:solidFill>
+                            <a:srgbClr val="0000FF"/>
+                          </a:solidFill>
+                          <a:effectLst/>
+                          <a:latin typeface="Microsoft GothicNeo" panose="020B0500000101010101" pitchFamily="50" charset="-127"/>
+                          <a:ea typeface="Microsoft GothicNeo" panose="020B0500000101010101" pitchFamily="50" charset="-127"/>
+                          <a:cs typeface="+mn-cs"/>
+                        </a:rPr>
+                        <a:t/>
+                      </a:r>
+                      <a:endParaRPr lang="en-US" altLang="ko-KR" sz="900" b="0" i="0" u="none" strike="noStrike" kern="1200" dirty="0">
+                        <a:solidFill>
+                          <a:srgbClr val="0000FF"/>
+                        </a:solidFill>
+                        <a:effectLst/>
+                        <a:latin typeface="Microsoft GothicNeo" panose="020B0500000101010101" pitchFamily="50" charset="-127"/>
+                        <a:ea typeface="Microsoft GothicNeo" panose="020B0500000101010101" pitchFamily="50" charset="-127"/>
+                        <a:cs typeface="+mn-cs"/>
+                      </a:endParaRPr>
+                    </a:p>
+                  </a:txBody>
+                  <a:tcPr marL="5721" marR="5721" marT="5721" marB="0" anchor="ctr"/>
+                </a:tc>
+                <a:tc>
+                  <a:txBody>
+                    <a:bodyPr/>
+                    <a:lstStyle/>
+                    <a:p>
+                      <a:pPr algn="r" fontAlgn="ctr">
+                        <a:buNone/>
+                      </a:pPr>
+                      <a:r>
+                        <a:rPr lang="ko-KR" altLang="en-US" sz="900" b="0" i="0" u="none" strike="noStrike" kern="1200" dirty="0">
+                          <a:solidFill>
+                            <a:srgbClr val="0000FF"/>
+                          </a:solidFill>
+                          <a:effectLst/>
+                          <a:latin typeface="Microsoft GothicNeo" panose="020B0500000101010101" pitchFamily="50" charset="-127"/>
+                          <a:ea typeface="Microsoft GothicNeo" panose="020B0500000101010101" pitchFamily="50" charset="-127"/>
+                          <a:cs typeface="+mn-cs"/>
+                        </a:rPr>
+                        <a:t/>
+                      </a:r>
+                      <a:endParaRPr lang="en-US" altLang="ko-KR" sz="900" b="0" i="0" u="none" strike="noStrike" kern="1200" dirty="0">
+                        <a:solidFill>
+                          <a:srgbClr val="0000FF"/>
+                        </a:solidFill>
+                        <a:effectLst/>
+                        <a:latin typeface="Microsoft GothicNeo" panose="020B0500000101010101" pitchFamily="50" charset="-127"/>
+                        <a:ea typeface="Microsoft GothicNeo" panose="020B0500000101010101" pitchFamily="50" charset="-127"/>
+                        <a:cs typeface="+mn-cs"/>
+                      </a:endParaRPr>
+                    </a:p>
+                  </a:txBody>
+                  <a:tcPr marL="5721" marR="5721" marT="5721" marB="0" anchor="ctr"/>
+                </a:tc>
+                <a:extLst>
+                  <a:ext uri="{0D108BD9-81ED-4DB2-BD59-A6C34878D82A}">
+                    <a16:rowId xmlns:a16="http://schemas.microsoft.com/office/drawing/2014/main" val="3639418345"/>
+                  </a:ext>
+                </a:extLst>
+              </a:tr>
+              <a:tr h="330000">
+                <a:tc>
+                  <a:txBody>
+                    <a:bodyPr/>
+                    <a:lstStyle/>
+                    <a:p>
+                      <a:pPr algn="ctr" fontAlgn="ctr">
+                        <a:buNone/>
+                      </a:pPr>
+                      <a:r>
+                        <a:rPr lang="en-US" altLang="ko-KR" sz="900" b="0" i="0" u="none" strike="noStrike" kern="1200">
+                          <a:solidFill>
+                            <a:srgbClr val="000000"/>
+                          </a:solidFill>
+                          <a:effectLst/>
+                          <a:latin typeface="Microsoft GothicNeo" panose="020B0500000101010101" pitchFamily="50" charset="-127"/>
+                          <a:ea typeface="Microsoft GothicNeo" panose="020B0500000101010101" pitchFamily="50" charset="-127"/>
+                          <a:cs typeface="+mn-cs"/>
+                        </a:rPr>
+                        <a:t>9</a:t>
+                      </a:r>
+                    </a:p>
+                  </a:txBody>
+                  <a:tcPr marL="5721" marR="5721" marT="5721" marB="0" anchor="ctr"/>
+                </a:tc>
+                <a:tc>
+                  <a:txBody>
+                    <a:bodyPr/>
+                    <a:lstStyle/>
+                    <a:p>
+                      <a:pPr algn="ctr" fontAlgn="ctr">
+                        <a:buNone/>
+                      </a:pPr>
+                      <a:r>
+                        <a:rPr lang="ko-KR" altLang="en-US" sz="900" b="0" i="0" u="none" strike="noStrike" kern="1200" dirty="0">
+                          <a:solidFill>
+                            <a:srgbClr val="000000"/>
+                          </a:solidFill>
+                          <a:effectLst/>
+                          <a:latin typeface="Microsoft GothicNeo" panose="020B0500000101010101" pitchFamily="50" charset="-127"/>
+                          <a:ea typeface="Microsoft GothicNeo" panose="020B0500000101010101" pitchFamily="50" charset="-127"/>
+                          <a:cs typeface="+mn-cs"/>
+                        </a:rPr>
+                        <a:t/>
+                      </a:r>
+                    </a:p>
+                  </a:txBody>
+                  <a:tcPr marL="5721" marR="5721" marT="5721" marB="0" anchor="ctr"/>
+                </a:tc>
+                <a:tc>
+                  <a:txBody>
+                    <a:bodyPr/>
+                    <a:lstStyle/>
+                    <a:p>
+                      <a:pPr algn="ctr" fontAlgn="ctr">
+                        <a:buNone/>
+                      </a:pPr>
+                      <a:r>
+                        <a:rPr lang="en-US" altLang="ko-KR" sz="900" b="0" i="0" u="none" strike="noStrike" kern="1200" dirty="0">
+                          <a:solidFill>
+                            <a:srgbClr val="0000FF"/>
+                          </a:solidFill>
+                          <a:effectLst/>
+                          <a:latin typeface="Microsoft GothicNeo" panose="020B0500000101010101" pitchFamily="50" charset="-127"/>
+                          <a:ea typeface="Microsoft GothicNeo" panose="020B0500000101010101" pitchFamily="50" charset="-127"/>
+                          <a:cs typeface="+mn-cs"/>
+                        </a:rPr>
+                        <a:t/>
+                      </a:r>
+                      <a:endParaRPr lang="ko-KR" altLang="en-US" sz="900" b="0" i="0" u="none" strike="noStrike" kern="1200" dirty="0">
+                        <a:solidFill>
+                          <a:srgbClr val="0000FF"/>
+                        </a:solidFill>
+                        <a:effectLst/>
+                        <a:latin typeface="Microsoft GothicNeo" panose="020B0500000101010101" pitchFamily="50" charset="-127"/>
+                        <a:ea typeface="Microsoft GothicNeo" panose="020B0500000101010101" pitchFamily="50" charset="-127"/>
+                        <a:cs typeface="+mn-cs"/>
+                      </a:endParaRPr>
+                    </a:p>
+                  </a:txBody>
+                  <a:tcPr marL="5721" marR="5721" marT="5721" marB="0" anchor="ctr"/>
+                </a:tc>
+                <a:tc>
+                  <a:txBody>
+                    <a:bodyPr/>
+                    <a:lstStyle/>
+                    <a:p>
+                      <a:pPr algn="ctr" fontAlgn="ctr">
+                        <a:buNone/>
+                      </a:pPr>
+                      <a:r>
+                        <a:rPr lang="ko-KR" altLang="en-US" sz="900" b="0" i="0" u="none" strike="noStrike" kern="1200" dirty="0">
+                          <a:solidFill>
+                            <a:srgbClr val="0000FF"/>
+                          </a:solidFill>
+                          <a:effectLst/>
+                          <a:latin typeface="Microsoft GothicNeo" panose="020B0500000101010101" pitchFamily="50" charset="-127"/>
+                          <a:ea typeface="Microsoft GothicNeo" panose="020B0500000101010101" pitchFamily="50" charset="-127"/>
+                          <a:cs typeface="+mn-cs"/>
+                        </a:rPr>
+                        <a:t/>
+                      </a:r>
+                      <a:endParaRPr lang="en-US" altLang="ko-KR" sz="900" b="0" i="0" u="none" strike="noStrike" kern="1200" dirty="0">
+                        <a:solidFill>
+                          <a:srgbClr val="0000FF"/>
+                        </a:solidFill>
+                        <a:effectLst/>
+                        <a:latin typeface="Microsoft GothicNeo" panose="020B0500000101010101" pitchFamily="50" charset="-127"/>
+                        <a:ea typeface="Microsoft GothicNeo" panose="020B0500000101010101" pitchFamily="50" charset="-127"/>
+                        <a:cs typeface="+mn-cs"/>
+                      </a:endParaRPr>
+                    </a:p>
+                  </a:txBody>
+                  <a:tcPr marL="5721" marR="5721" marT="5721" marB="0" anchor="ctr"/>
+                </a:tc>
+                <a:tc>
+                  <a:txBody>
+                    <a:bodyPr/>
+                    <a:lstStyle/>
+                    <a:p>
+                      <a:pPr algn="r" fontAlgn="ctr">
+                        <a:buNone/>
+                      </a:pPr>
+                      <a:r>
+                        <a:rPr lang="ko-KR" altLang="en-US" sz="900" b="0" i="0" u="none" strike="noStrike" kern="1200" dirty="0">
+                          <a:solidFill>
+                            <a:srgbClr val="0000FF"/>
+                          </a:solidFill>
+                          <a:effectLst/>
+                          <a:latin typeface="Microsoft GothicNeo" panose="020B0500000101010101" pitchFamily="50" charset="-127"/>
+                          <a:ea typeface="Microsoft GothicNeo" panose="020B0500000101010101" pitchFamily="50" charset="-127"/>
+                          <a:cs typeface="+mn-cs"/>
+                        </a:rPr>
+                        <a:t/>
+                      </a:r>
+                      <a:endParaRPr lang="en-US" altLang="ko-KR" sz="900" b="0" i="0" u="none" strike="noStrike" kern="1200" dirty="0">
+                        <a:solidFill>
+                          <a:srgbClr val="0000FF"/>
+                        </a:solidFill>
+                        <a:effectLst/>
+                        <a:latin typeface="Microsoft GothicNeo" panose="020B0500000101010101" pitchFamily="50" charset="-127"/>
+                        <a:ea typeface="Microsoft GothicNeo" panose="020B0500000101010101" pitchFamily="50" charset="-127"/>
+                        <a:cs typeface="+mn-cs"/>
+                      </a:endParaRPr>
+                    </a:p>
+                  </a:txBody>
+                  <a:tcPr marL="5721" marR="5721" marT="5721" marB="0" anchor="ctr"/>
+                </a:tc>
+                <a:extLst>
+                  <a:ext uri="{0D108BD9-81ED-4DB2-BD59-A6C34878D82A}">
+                    <a16:rowId xmlns:a16="http://schemas.microsoft.com/office/drawing/2014/main" val="3639418345"/>
+                  </a:ext>
+                </a:extLst>
+              </a:tr>
+              <a:tr h="330000">
+                <a:tc>
+                  <a:txBody>
+                    <a:bodyPr/>
+                    <a:lstStyle/>
+                    <a:p>
+                      <a:pPr algn="ctr" fontAlgn="ctr">
+                        <a:buNone/>
+                      </a:pPr>
+                      <a:r>
+                        <a:rPr lang="en-US" altLang="ko-KR" sz="900" b="0" i="0" u="none" strike="noStrike" kern="1200">
+                          <a:solidFill>
+                            <a:srgbClr val="000000"/>
+                          </a:solidFill>
+                          <a:effectLst/>
+                          <a:latin typeface="Microsoft GothicNeo" panose="020B0500000101010101" pitchFamily="50" charset="-127"/>
+                          <a:ea typeface="Microsoft GothicNeo" panose="020B0500000101010101" pitchFamily="50" charset="-127"/>
+                          <a:cs typeface="+mn-cs"/>
+                        </a:rPr>
+                        <a:t>10</a:t>
+                      </a:r>
+                    </a:p>
+                  </a:txBody>
+                  <a:tcPr marL="5721" marR="5721" marT="5721" marB="0" anchor="ctr"/>
+                </a:tc>
+                <a:tc>
+                  <a:txBody>
+                    <a:bodyPr/>
+                    <a:lstStyle/>
+                    <a:p>
+                      <a:pPr algn="ctr" fontAlgn="ctr">
+                        <a:buNone/>
+                      </a:pPr>
+                      <a:r>
+                        <a:rPr lang="ko-KR" altLang="en-US" sz="900" b="0" i="0" u="none" strike="noStrike" kern="1200" dirty="0">
+                          <a:solidFill>
+                            <a:srgbClr val="000000"/>
+                          </a:solidFill>
+                          <a:effectLst/>
+                          <a:latin typeface="Microsoft GothicNeo" panose="020B0500000101010101" pitchFamily="50" charset="-127"/>
+                          <a:ea typeface="Microsoft GothicNeo" panose="020B0500000101010101" pitchFamily="50" charset="-127"/>
+                          <a:cs typeface="+mn-cs"/>
+                        </a:rPr>
+                        <a:t/>
+                      </a:r>
+                    </a:p>
+                  </a:txBody>
+                  <a:tcPr marL="5721" marR="5721" marT="5721" marB="0" anchor="ctr"/>
+                </a:tc>
+                <a:tc>
+                  <a:txBody>
+                    <a:bodyPr/>
+                    <a:lstStyle/>
+                    <a:p>
+                      <a:pPr algn="ctr" fontAlgn="ctr">
+                        <a:buNone/>
+                      </a:pPr>
+                      <a:r>
+                        <a:rPr lang="en-US" altLang="ko-KR" sz="900" b="0" i="0" u="none" strike="noStrike" kern="1200" dirty="0">
+                          <a:solidFill>
+                            <a:srgbClr val="0000FF"/>
+                          </a:solidFill>
+                          <a:effectLst/>
+                          <a:latin typeface="Microsoft GothicNeo" panose="020B0500000101010101" pitchFamily="50" charset="-127"/>
+                          <a:ea typeface="Microsoft GothicNeo" panose="020B0500000101010101" pitchFamily="50" charset="-127"/>
+                          <a:cs typeface="+mn-cs"/>
+                        </a:rPr>
+                        <a:t/>
+                      </a:r>
+                      <a:endParaRPr lang="ko-KR" altLang="en-US" sz="900" b="0" i="0" u="none" strike="noStrike" kern="1200" dirty="0">
+                        <a:solidFill>
+                          <a:srgbClr val="0000FF"/>
+                        </a:solidFill>
+                        <a:effectLst/>
+                        <a:latin typeface="Microsoft GothicNeo" panose="020B0500000101010101" pitchFamily="50" charset="-127"/>
+                        <a:ea typeface="Microsoft GothicNeo" panose="020B0500000101010101" pitchFamily="50" charset="-127"/>
+                        <a:cs typeface="+mn-cs"/>
+                      </a:endParaRPr>
+                    </a:p>
+                  </a:txBody>
+                  <a:tcPr marL="5721" marR="5721" marT="5721" marB="0" anchor="ctr"/>
+                </a:tc>
+                <a:tc>
+                  <a:txBody>
+                    <a:bodyPr/>
+                    <a:lstStyle/>
+                    <a:p>
+                      <a:pPr algn="ctr" fontAlgn="ctr">
+                        <a:buNone/>
+                      </a:pPr>
+                      <a:r>
+                        <a:rPr lang="ko-KR" altLang="en-US" sz="900" b="0" i="0" u="none" strike="noStrike" kern="1200" dirty="0">
+                          <a:solidFill>
+                            <a:srgbClr val="0000FF"/>
+                          </a:solidFill>
+                          <a:effectLst/>
+                          <a:latin typeface="Microsoft GothicNeo" panose="020B0500000101010101" pitchFamily="50" charset="-127"/>
+                          <a:ea typeface="Microsoft GothicNeo" panose="020B0500000101010101" pitchFamily="50" charset="-127"/>
+                          <a:cs typeface="+mn-cs"/>
+                        </a:rPr>
+                        <a:t/>
+                      </a:r>
+                      <a:endParaRPr lang="en-US" altLang="ko-KR" sz="900" b="0" i="0" u="none" strike="noStrike" kern="1200" dirty="0">
+                        <a:solidFill>
+                          <a:srgbClr val="0000FF"/>
+                        </a:solidFill>
+                        <a:effectLst/>
+                        <a:latin typeface="Microsoft GothicNeo" panose="020B0500000101010101" pitchFamily="50" charset="-127"/>
+                        <a:ea typeface="Microsoft GothicNeo" panose="020B0500000101010101" pitchFamily="50" charset="-127"/>
+                        <a:cs typeface="+mn-cs"/>
+                      </a:endParaRPr>
+                    </a:p>
+                  </a:txBody>
+                  <a:tcPr marL="5721" marR="5721" marT="5721" marB="0" anchor="ctr"/>
+                </a:tc>
+                <a:tc>
+                  <a:txBody>
+                    <a:bodyPr/>
+                    <a:lstStyle/>
+                    <a:p>
+                      <a:pPr algn="r" fontAlgn="ctr">
+                        <a:buNone/>
+                      </a:pPr>
+                      <a:r>
+                        <a:rPr lang="ko-KR" altLang="en-US" sz="900" b="0" i="0" u="none" strike="noStrike" kern="1200" dirty="0">
+                          <a:solidFill>
+                            <a:srgbClr val="0000FF"/>
+                          </a:solidFill>
+                          <a:effectLst/>
+                          <a:latin typeface="Microsoft GothicNeo" panose="020B0500000101010101" pitchFamily="50" charset="-127"/>
+                          <a:ea typeface="Microsoft GothicNeo" panose="020B0500000101010101" pitchFamily="50" charset="-127"/>
+                          <a:cs typeface="+mn-cs"/>
+                        </a:rPr>
+                        <a:t/>
+                      </a:r>
+                      <a:endParaRPr lang="en-US" altLang="ko-KR" sz="900" b="0" i="0" u="none" strike="noStrike" kern="1200" dirty="0">
+                        <a:solidFill>
+                          <a:srgbClr val="0000FF"/>
+                        </a:solidFill>
+                        <a:effectLst/>
+                        <a:latin typeface="Microsoft GothicNeo" panose="020B0500000101010101" pitchFamily="50" charset="-127"/>
+                        <a:ea typeface="Microsoft GothicNeo" panose="020B0500000101010101" pitchFamily="50" charset="-127"/>
+                        <a:cs typeface="+mn-cs"/>
+                      </a:endParaRPr>
+                    </a:p>
+                  </a:txBody>
+                  <a:tcPr marL="5721" marR="5721" marT="5721" marB="0" anchor="ctr"/>
+                </a:tc>
+                <a:extLst>
+                  <a:ext uri="{0D108BD9-81ED-4DB2-BD59-A6C34878D82A}">
+                    <a16:rowId xmlns:a16="http://schemas.microsoft.com/office/drawing/2014/main" val="3639418345"/>
+                  </a:ext>
+                </a:extLst>
+              </a:tr>
+              <a:tr h="330000">
+                <a:tc>
+                  <a:txBody>
+                    <a:bodyPr/>
+                    <a:lstStyle/>
+                    <a:p>
+                      <a:pPr algn="ctr" fontAlgn="ctr">
+                        <a:buNone/>
+                      </a:pPr>
+                      <a:r>
+                        <a:rPr lang="en-US" altLang="ko-KR" sz="900" b="0" i="0" u="none" strike="noStrike" kern="1200">
+                          <a:solidFill>
+                            <a:srgbClr val="000000"/>
+                          </a:solidFill>
+                          <a:effectLst/>
+                          <a:latin typeface="Microsoft GothicNeo" panose="020B0500000101010101" pitchFamily="50" charset="-127"/>
+                          <a:ea typeface="Microsoft GothicNeo" panose="020B0500000101010101" pitchFamily="50" charset="-127"/>
+                          <a:cs typeface="+mn-cs"/>
+                        </a:rPr>
+                        <a:t>11</a:t>
+                      </a:r>
+                    </a:p>
+                  </a:txBody>
+                  <a:tcPr marL="5721" marR="5721" marT="5721" marB="0" anchor="ctr"/>
+                </a:tc>
+                <a:tc>
+                  <a:txBody>
+                    <a:bodyPr/>
+                    <a:lstStyle/>
+                    <a:p>
+                      <a:pPr algn="ctr" fontAlgn="ctr">
+                        <a:buNone/>
+                      </a:pPr>
+                      <a:r>
+                        <a:rPr lang="ko-KR" altLang="en-US" sz="900" b="0" i="0" u="none" strike="noStrike" kern="1200" dirty="0">
+                          <a:solidFill>
+                            <a:srgbClr val="000000"/>
+                          </a:solidFill>
+                          <a:effectLst/>
+                          <a:latin typeface="Microsoft GothicNeo" panose="020B0500000101010101" pitchFamily="50" charset="-127"/>
+                          <a:ea typeface="Microsoft GothicNeo" panose="020B0500000101010101" pitchFamily="50" charset="-127"/>
+                          <a:cs typeface="+mn-cs"/>
+                        </a:rPr>
+                        <a:t/>
+                      </a:r>
+                    </a:p>
+                  </a:txBody>
+                  <a:tcPr marL="5721" marR="5721" marT="5721" marB="0" anchor="ctr"/>
+                </a:tc>
+                <a:tc>
+                  <a:txBody>
+                    <a:bodyPr/>
+                    <a:lstStyle/>
+                    <a:p>
+                      <a:pPr algn="ctr" fontAlgn="ctr">
+                        <a:buNone/>
+                      </a:pPr>
+                      <a:r>
+                        <a:rPr lang="en-US" altLang="ko-KR" sz="900" b="0" i="0" u="none" strike="noStrike" kern="1200" dirty="0">
+                          <a:solidFill>
+                            <a:srgbClr val="0000FF"/>
+                          </a:solidFill>
+                          <a:effectLst/>
+                          <a:latin typeface="Microsoft GothicNeo" panose="020B0500000101010101" pitchFamily="50" charset="-127"/>
+                          <a:ea typeface="Microsoft GothicNeo" panose="020B0500000101010101" pitchFamily="50" charset="-127"/>
+                          <a:cs typeface="+mn-cs"/>
+                        </a:rPr>
+                        <a:t/>
+                      </a:r>
+                      <a:endParaRPr lang="ko-KR" altLang="en-US" sz="900" b="0" i="0" u="none" strike="noStrike" kern="1200" dirty="0">
+                        <a:solidFill>
+                          <a:srgbClr val="0000FF"/>
+                        </a:solidFill>
+                        <a:effectLst/>
+                        <a:latin typeface="Microsoft GothicNeo" panose="020B0500000101010101" pitchFamily="50" charset="-127"/>
+                        <a:ea typeface="Microsoft GothicNeo" panose="020B0500000101010101" pitchFamily="50" charset="-127"/>
+                        <a:cs typeface="+mn-cs"/>
+                      </a:endParaRPr>
+                    </a:p>
+                  </a:txBody>
+                  <a:tcPr marL="5721" marR="5721" marT="5721" marB="0" anchor="ctr"/>
+                </a:tc>
+                <a:tc>
+                  <a:txBody>
+                    <a:bodyPr/>
+                    <a:lstStyle/>
+                    <a:p>
+                      <a:pPr algn="ctr" fontAlgn="ctr">
+                        <a:buNone/>
+                      </a:pPr>
+                      <a:r>
+                        <a:rPr lang="ko-KR" altLang="en-US" sz="900" b="0" i="0" u="none" strike="noStrike" kern="1200" dirty="0">
+                          <a:solidFill>
+                            <a:srgbClr val="0000FF"/>
+                          </a:solidFill>
+                          <a:effectLst/>
+                          <a:latin typeface="Microsoft GothicNeo" panose="020B0500000101010101" pitchFamily="50" charset="-127"/>
+                          <a:ea typeface="Microsoft GothicNeo" panose="020B0500000101010101" pitchFamily="50" charset="-127"/>
+                          <a:cs typeface="+mn-cs"/>
+                        </a:rPr>
+                        <a:t/>
+                      </a:r>
+                      <a:endParaRPr lang="en-US" altLang="ko-KR" sz="900" b="0" i="0" u="none" strike="noStrike" kern="1200" dirty="0">
+                        <a:solidFill>
+                          <a:srgbClr val="0000FF"/>
+                        </a:solidFill>
+                        <a:effectLst/>
+                        <a:latin typeface="Microsoft GothicNeo" panose="020B0500000101010101" pitchFamily="50" charset="-127"/>
+                        <a:ea typeface="Microsoft GothicNeo" panose="020B0500000101010101" pitchFamily="50" charset="-127"/>
+                        <a:cs typeface="+mn-cs"/>
+                      </a:endParaRPr>
+                    </a:p>
+                  </a:txBody>
+                  <a:tcPr marL="5721" marR="5721" marT="5721" marB="0" anchor="ctr"/>
+                </a:tc>
+                <a:tc>
+                  <a:txBody>
+                    <a:bodyPr/>
+                    <a:lstStyle/>
+                    <a:p>
+                      <a:pPr algn="r" fontAlgn="ctr">
+                        <a:buNone/>
+                      </a:pPr>
+                      <a:r>
+                        <a:rPr lang="ko-KR" altLang="en-US" sz="900" b="0" i="0" u="none" strike="noStrike" kern="1200" dirty="0">
+                          <a:solidFill>
+                            <a:srgbClr val="0000FF"/>
+                          </a:solidFill>
+                          <a:effectLst/>
+                          <a:latin typeface="Microsoft GothicNeo" panose="020B0500000101010101" pitchFamily="50" charset="-127"/>
+                          <a:ea typeface="Microsoft GothicNeo" panose="020B0500000101010101" pitchFamily="50" charset="-127"/>
+                          <a:cs typeface="+mn-cs"/>
+                        </a:rPr>
+                        <a:t/>
+                      </a:r>
+                      <a:endParaRPr lang="en-US" altLang="ko-KR" sz="900" b="0" i="0" u="none" strike="noStrike" kern="1200" dirty="0">
+                        <a:solidFill>
+                          <a:srgbClr val="0000FF"/>
+                        </a:solidFill>
+                        <a:effectLst/>
+                        <a:latin typeface="Microsoft GothicNeo" panose="020B0500000101010101" pitchFamily="50" charset="-127"/>
+                        <a:ea typeface="Microsoft GothicNeo" panose="020B0500000101010101" pitchFamily="50" charset="-127"/>
+                        <a:cs typeface="+mn-cs"/>
+                      </a:endParaRPr>
+                    </a:p>
+                  </a:txBody>
+                  <a:tcPr marL="5721" marR="5721" marT="5721" marB="0" anchor="ctr"/>
+                </a:tc>
+                <a:extLst>
+                  <a:ext uri="{0D108BD9-81ED-4DB2-BD59-A6C34878D82A}">
+                    <a16:rowId xmlns:a16="http://schemas.microsoft.com/office/drawing/2014/main" val="3639418345"/>
+                  </a:ext>
+                </a:extLst>
+              </a:tr>
+              <a:tr h="330000">
+                <a:tc>
+                  <a:txBody>
+                    <a:bodyPr/>
+                    <a:lstStyle/>
+                    <a:p>
+                      <a:pPr algn="ctr" fontAlgn="ctr">
+                        <a:buNone/>
+                      </a:pPr>
+                      <a:r>
+                        <a:rPr lang="en-US" altLang="ko-KR" sz="900" b="0" i="0" u="none" strike="noStrike" kern="1200">
+                          <a:solidFill>
+                            <a:srgbClr val="000000"/>
+                          </a:solidFill>
+                          <a:effectLst/>
+                          <a:latin typeface="Microsoft GothicNeo" panose="020B0500000101010101" pitchFamily="50" charset="-127"/>
+                          <a:ea typeface="Microsoft GothicNeo" panose="020B0500000101010101" pitchFamily="50" charset="-127"/>
+                          <a:cs typeface="+mn-cs"/>
+                        </a:rPr>
+                        <a:t>12</a:t>
+                      </a:r>
+                    </a:p>
+                  </a:txBody>
+                  <a:tcPr marL="5721" marR="5721" marT="5721" marB="0" anchor="ctr"/>
+                </a:tc>
+                <a:tc>
+                  <a:txBody>
+                    <a:bodyPr/>
+                    <a:lstStyle/>
+                    <a:p>
+                      <a:pPr algn="ctr" fontAlgn="ctr">
+                        <a:buNone/>
+                      </a:pPr>
+                      <a:r>
+                        <a:rPr lang="ko-KR" altLang="en-US" sz="900" b="0" i="0" u="none" strike="noStrike" kern="1200" dirty="0">
+                          <a:solidFill>
+                            <a:srgbClr val="000000"/>
+                          </a:solidFill>
+                          <a:effectLst/>
+                          <a:latin typeface="Microsoft GothicNeo" panose="020B0500000101010101" pitchFamily="50" charset="-127"/>
+                          <a:ea typeface="Microsoft GothicNeo" panose="020B0500000101010101" pitchFamily="50" charset="-127"/>
+                          <a:cs typeface="+mn-cs"/>
+                        </a:rPr>
+                        <a:t/>
+                      </a:r>
+                    </a:p>
+                  </a:txBody>
+                  <a:tcPr marL="5721" marR="5721" marT="5721" marB="0" anchor="ctr"/>
+                </a:tc>
+                <a:tc>
+                  <a:txBody>
+                    <a:bodyPr/>
+                    <a:lstStyle/>
+                    <a:p>
+                      <a:pPr algn="ctr" fontAlgn="ctr">
+                        <a:buNone/>
+                      </a:pPr>
+                      <a:r>
+                        <a:rPr lang="en-US" altLang="ko-KR" sz="900" b="0" i="0" u="none" strike="noStrike" kern="1200" dirty="0">
+                          <a:solidFill>
+                            <a:srgbClr val="0000FF"/>
+                          </a:solidFill>
+                          <a:effectLst/>
+                          <a:latin typeface="Microsoft GothicNeo" panose="020B0500000101010101" pitchFamily="50" charset="-127"/>
+                          <a:ea typeface="Microsoft GothicNeo" panose="020B0500000101010101" pitchFamily="50" charset="-127"/>
+                          <a:cs typeface="+mn-cs"/>
+                        </a:rPr>
+                        <a:t/>
+                      </a:r>
+                      <a:endParaRPr lang="ko-KR" altLang="en-US" sz="900" b="0" i="0" u="none" strike="noStrike" kern="1200" dirty="0">
+                        <a:solidFill>
+                          <a:srgbClr val="0000FF"/>
+                        </a:solidFill>
+                        <a:effectLst/>
+                        <a:latin typeface="Microsoft GothicNeo" panose="020B0500000101010101" pitchFamily="50" charset="-127"/>
+                        <a:ea typeface="Microsoft GothicNeo" panose="020B0500000101010101" pitchFamily="50" charset="-127"/>
+                        <a:cs typeface="+mn-cs"/>
+                      </a:endParaRPr>
+                    </a:p>
+                  </a:txBody>
+                  <a:tcPr marL="5721" marR="5721" marT="5721" marB="0" anchor="ctr"/>
+                </a:tc>
+                <a:tc>
+                  <a:txBody>
+                    <a:bodyPr/>
+                    <a:lstStyle/>
+                    <a:p>
+                      <a:pPr algn="ctr" fontAlgn="ctr">
+                        <a:buNone/>
+                      </a:pPr>
+                      <a:r>
+                        <a:rPr lang="ko-KR" altLang="en-US" sz="900" b="0" i="0" u="none" strike="noStrike" kern="1200" dirty="0">
+                          <a:solidFill>
+                            <a:srgbClr val="0000FF"/>
+                          </a:solidFill>
+                          <a:effectLst/>
+                          <a:latin typeface="Microsoft GothicNeo" panose="020B0500000101010101" pitchFamily="50" charset="-127"/>
+                          <a:ea typeface="Microsoft GothicNeo" panose="020B0500000101010101" pitchFamily="50" charset="-127"/>
+                          <a:cs typeface="+mn-cs"/>
+                        </a:rPr>
+                        <a:t/>
+                      </a:r>
+                      <a:endParaRPr lang="en-US" altLang="ko-KR" sz="900" b="0" i="0" u="none" strike="noStrike" kern="1200" dirty="0">
+                        <a:solidFill>
+                          <a:srgbClr val="0000FF"/>
+                        </a:solidFill>
+                        <a:effectLst/>
+                        <a:latin typeface="Microsoft GothicNeo" panose="020B0500000101010101" pitchFamily="50" charset="-127"/>
+                        <a:ea typeface="Microsoft GothicNeo" panose="020B0500000101010101" pitchFamily="50" charset="-127"/>
+                        <a:cs typeface="+mn-cs"/>
+                      </a:endParaRPr>
+                    </a:p>
+                  </a:txBody>
+                  <a:tcPr marL="5721" marR="5721" marT="5721" marB="0" anchor="ctr"/>
+                </a:tc>
+                <a:tc>
+                  <a:txBody>
+                    <a:bodyPr/>
+                    <a:lstStyle/>
+                    <a:p>
+                      <a:pPr algn="r" fontAlgn="ctr">
+                        <a:buNone/>
+                      </a:pPr>
+                      <a:r>
+                        <a:rPr lang="ko-KR" altLang="en-US" sz="900" b="0" i="0" u="none" strike="noStrike" kern="1200" dirty="0">
+                          <a:solidFill>
+                            <a:srgbClr val="0000FF"/>
+                          </a:solidFill>
+                          <a:effectLst/>
+                          <a:latin typeface="Microsoft GothicNeo" panose="020B0500000101010101" pitchFamily="50" charset="-127"/>
+                          <a:ea typeface="Microsoft GothicNeo" panose="020B0500000101010101" pitchFamily="50" charset="-127"/>
+                          <a:cs typeface="+mn-cs"/>
+                        </a:rPr>
+                        <a:t/>
+                      </a:r>
+                      <a:endParaRPr lang="en-US" altLang="ko-KR" sz="900" b="0" i="0" u="none" strike="noStrike" kern="1200" dirty="0">
+                        <a:solidFill>
+                          <a:srgbClr val="0000FF"/>
+                        </a:solidFill>
+                        <a:effectLst/>
+                        <a:latin typeface="Microsoft GothicNeo" panose="020B0500000101010101" pitchFamily="50" charset="-127"/>
+                        <a:ea typeface="Microsoft GothicNeo" panose="020B0500000101010101" pitchFamily="50" charset="-127"/>
+                        <a:cs typeface="+mn-cs"/>
+                      </a:endParaRPr>
+                    </a:p>
+                  </a:txBody>
+                  <a:tcPr marL="5721" marR="5721" marT="5721" marB="0" anchor="ctr"/>
+                </a:tc>
+                <a:extLst>
+                  <a:ext uri="{0D108BD9-81ED-4DB2-BD59-A6C34878D82A}">
+                    <a16:rowId xmlns:a16="http://schemas.microsoft.com/office/drawing/2014/main" val="3639418345"/>
+                  </a:ext>
+                </a:extLst>
+              </a:tr>
+              <a:tr h="330000">
+                <a:tc>
+                  <a:txBody>
+                    <a:bodyPr/>
+                    <a:lstStyle/>
+                    <a:p>
+                      <a:pPr algn="ctr" fontAlgn="ctr">
+                        <a:buNone/>
+                      </a:pPr>
+                      <a:r>
+                        <a:rPr lang="en-US" altLang="ko-KR" sz="900" b="0" i="0" u="none" strike="noStrike" kern="1200">
+                          <a:solidFill>
+                            <a:srgbClr val="000000"/>
+                          </a:solidFill>
+                          <a:effectLst/>
+                          <a:latin typeface="Microsoft GothicNeo" panose="020B0500000101010101" pitchFamily="50" charset="-127"/>
+                          <a:ea typeface="Microsoft GothicNeo" panose="020B0500000101010101" pitchFamily="50" charset="-127"/>
+                          <a:cs typeface="+mn-cs"/>
+                        </a:rPr>
+                        <a:t>13</a:t>
+                      </a:r>
+                    </a:p>
+                  </a:txBody>
+                  <a:tcPr marL="5721" marR="5721" marT="5721" marB="0" anchor="ctr"/>
+                </a:tc>
+                <a:tc>
+                  <a:txBody>
+                    <a:bodyPr/>
+                    <a:lstStyle/>
+                    <a:p>
+                      <a:pPr algn="ctr" fontAlgn="ctr">
+                        <a:buNone/>
+                      </a:pPr>
+                      <a:r>
+                        <a:rPr lang="ko-KR" altLang="en-US" sz="900" b="0" i="0" u="none" strike="noStrike" kern="1200" dirty="0">
+                          <a:solidFill>
+                            <a:srgbClr val="000000"/>
+                          </a:solidFill>
+                          <a:effectLst/>
+                          <a:latin typeface="Microsoft GothicNeo" panose="020B0500000101010101" pitchFamily="50" charset="-127"/>
+                          <a:ea typeface="Microsoft GothicNeo" panose="020B0500000101010101" pitchFamily="50" charset="-127"/>
+                          <a:cs typeface="+mn-cs"/>
+                        </a:rPr>
+                        <a:t/>
+                      </a:r>
+                    </a:p>
+                  </a:txBody>
+                  <a:tcPr marL="5721" marR="5721" marT="5721" marB="0" anchor="ctr"/>
+                </a:tc>
+                <a:tc>
+                  <a:txBody>
+                    <a:bodyPr/>
+                    <a:lstStyle/>
+                    <a:p>
+                      <a:pPr algn="ctr" fontAlgn="ctr">
+                        <a:buNone/>
+                      </a:pPr>
+                      <a:r>
+                        <a:rPr lang="en-US" altLang="ko-KR" sz="900" b="0" i="0" u="none" strike="noStrike" kern="1200" dirty="0">
+                          <a:solidFill>
+                            <a:srgbClr val="0000FF"/>
+                          </a:solidFill>
+                          <a:effectLst/>
+                          <a:latin typeface="Microsoft GothicNeo" panose="020B0500000101010101" pitchFamily="50" charset="-127"/>
+                          <a:ea typeface="Microsoft GothicNeo" panose="020B0500000101010101" pitchFamily="50" charset="-127"/>
+                          <a:cs typeface="+mn-cs"/>
+                        </a:rPr>
+                        <a:t/>
+                      </a:r>
+                      <a:endParaRPr lang="ko-KR" altLang="en-US" sz="900" b="0" i="0" u="none" strike="noStrike" kern="1200" dirty="0">
+                        <a:solidFill>
+                          <a:srgbClr val="0000FF"/>
+                        </a:solidFill>
+                        <a:effectLst/>
+                        <a:latin typeface="Microsoft GothicNeo" panose="020B0500000101010101" pitchFamily="50" charset="-127"/>
+                        <a:ea typeface="Microsoft GothicNeo" panose="020B0500000101010101" pitchFamily="50" charset="-127"/>
+                        <a:cs typeface="+mn-cs"/>
+                      </a:endParaRPr>
+                    </a:p>
+                  </a:txBody>
+                  <a:tcPr marL="5721" marR="5721" marT="5721" marB="0" anchor="ctr"/>
+                </a:tc>
+                <a:tc>
+                  <a:txBody>
+                    <a:bodyPr/>
+                    <a:lstStyle/>
+                    <a:p>
+                      <a:pPr algn="ctr" fontAlgn="ctr">
+                        <a:buNone/>
+                      </a:pPr>
+                      <a:r>
+                        <a:rPr lang="ko-KR" altLang="en-US" sz="900" b="0" i="0" u="none" strike="noStrike" kern="1200" dirty="0">
+                          <a:solidFill>
+                            <a:srgbClr val="0000FF"/>
+                          </a:solidFill>
+                          <a:effectLst/>
+                          <a:latin typeface="Microsoft GothicNeo" panose="020B0500000101010101" pitchFamily="50" charset="-127"/>
+                          <a:ea typeface="Microsoft GothicNeo" panose="020B0500000101010101" pitchFamily="50" charset="-127"/>
+                          <a:cs typeface="+mn-cs"/>
+                        </a:rPr>
+                        <a:t/>
+                      </a:r>
+                      <a:endParaRPr lang="en-US" altLang="ko-KR" sz="900" b="0" i="0" u="none" strike="noStrike" kern="1200" dirty="0">
+                        <a:solidFill>
+                          <a:srgbClr val="0000FF"/>
+                        </a:solidFill>
+                        <a:effectLst/>
+                        <a:latin typeface="Microsoft GothicNeo" panose="020B0500000101010101" pitchFamily="50" charset="-127"/>
+                        <a:ea typeface="Microsoft GothicNeo" panose="020B0500000101010101" pitchFamily="50" charset="-127"/>
+                        <a:cs typeface="+mn-cs"/>
+                      </a:endParaRPr>
+                    </a:p>
+                  </a:txBody>
+                  <a:tcPr marL="5721" marR="5721" marT="5721" marB="0" anchor="ctr"/>
+                </a:tc>
+                <a:tc>
+                  <a:txBody>
+                    <a:bodyPr/>
+                    <a:lstStyle/>
+                    <a:p>
+                      <a:pPr algn="r" fontAlgn="ctr">
+                        <a:buNone/>
+                      </a:pPr>
+                      <a:r>
+                        <a:rPr lang="ko-KR" altLang="en-US" sz="900" b="0" i="0" u="none" strike="noStrike" kern="1200" dirty="0">
+                          <a:solidFill>
+                            <a:srgbClr val="0000FF"/>
+                          </a:solidFill>
+                          <a:effectLst/>
+                          <a:latin typeface="Microsoft GothicNeo" panose="020B0500000101010101" pitchFamily="50" charset="-127"/>
+                          <a:ea typeface="Microsoft GothicNeo" panose="020B0500000101010101" pitchFamily="50" charset="-127"/>
+                          <a:cs typeface="+mn-cs"/>
+                        </a:rPr>
+                        <a:t/>
+                      </a:r>
+                      <a:endParaRPr lang="en-US" altLang="ko-KR" sz="900" b="0" i="0" u="none" strike="noStrike" kern="1200" dirty="0">
+                        <a:solidFill>
+                          <a:srgbClr val="0000FF"/>
+                        </a:solidFill>
+                        <a:effectLst/>
+                        <a:latin typeface="Microsoft GothicNeo" panose="020B0500000101010101" pitchFamily="50" charset="-127"/>
+                        <a:ea typeface="Microsoft GothicNeo" panose="020B0500000101010101" pitchFamily="50" charset="-127"/>
+                        <a:cs typeface="+mn-cs"/>
+                      </a:endParaRPr>
+                    </a:p>
+                  </a:txBody>
+                  <a:tcPr marL="5721" marR="5721" marT="5721" marB="0" anchor="ctr"/>
+                </a:tc>
+                <a:extLst>
+                  <a:ext uri="{0D108BD9-81ED-4DB2-BD59-A6C34878D82A}">
+                    <a16:rowId xmlns:a16="http://schemas.microsoft.com/office/drawing/2014/main" val="3639418345"/>
+                  </a:ext>
+                </a:extLst>
+              </a:tr>
+              <a:tr h="330000">
+                <a:tc>
+                  <a:txBody>
+                    <a:bodyPr/>
+                    <a:lstStyle/>
+                    <a:p>
+                      <a:pPr algn="ctr" fontAlgn="ctr">
+                        <a:buNone/>
+                      </a:pPr>
+                      <a:r>
+                        <a:rPr lang="en-US" altLang="ko-KR" sz="900" b="0" i="0" u="none" strike="noStrike" kern="1200">
+                          <a:solidFill>
+                            <a:srgbClr val="000000"/>
+                          </a:solidFill>
+                          <a:effectLst/>
+                          <a:latin typeface="Microsoft GothicNeo" panose="020B0500000101010101" pitchFamily="50" charset="-127"/>
+                          <a:ea typeface="Microsoft GothicNeo" panose="020B0500000101010101" pitchFamily="50" charset="-127"/>
+                          <a:cs typeface="+mn-cs"/>
+                        </a:rPr>
+                        <a:t>14</a:t>
+                      </a:r>
+                    </a:p>
+                  </a:txBody>
+                  <a:tcPr marL="5721" marR="5721" marT="5721" marB="0" anchor="ctr"/>
+                </a:tc>
+                <a:tc>
+                  <a:txBody>
+                    <a:bodyPr/>
+                    <a:lstStyle/>
+                    <a:p>
+                      <a:pPr algn="ctr" fontAlgn="ctr">
+                        <a:buNone/>
+                      </a:pPr>
+                      <a:r>
+                        <a:rPr lang="ko-KR" altLang="en-US" sz="900" b="0" i="0" u="none" strike="noStrike" kern="1200" dirty="0">
+                          <a:solidFill>
+                            <a:srgbClr val="000000"/>
+                          </a:solidFill>
+                          <a:effectLst/>
+                          <a:latin typeface="Microsoft GothicNeo" panose="020B0500000101010101" pitchFamily="50" charset="-127"/>
+                          <a:ea typeface="Microsoft GothicNeo" panose="020B0500000101010101" pitchFamily="50" charset="-127"/>
+                          <a:cs typeface="+mn-cs"/>
+                        </a:rPr>
+                        <a:t/>
+                      </a:r>
+                    </a:p>
+                  </a:txBody>
+                  <a:tcPr marL="5721" marR="5721" marT="5721" marB="0" anchor="ctr"/>
+                </a:tc>
+                <a:tc>
+                  <a:txBody>
+                    <a:bodyPr/>
+                    <a:lstStyle/>
+                    <a:p>
+                      <a:pPr algn="ctr" fontAlgn="ctr">
+                        <a:buNone/>
+                      </a:pPr>
+                      <a:r>
+                        <a:rPr lang="en-US" altLang="ko-KR" sz="900" b="0" i="0" u="none" strike="noStrike" kern="1200" dirty="0">
+                          <a:solidFill>
+                            <a:srgbClr val="0000FF"/>
+                          </a:solidFill>
+                          <a:effectLst/>
+                          <a:latin typeface="Microsoft GothicNeo" panose="020B0500000101010101" pitchFamily="50" charset="-127"/>
+                          <a:ea typeface="Microsoft GothicNeo" panose="020B0500000101010101" pitchFamily="50" charset="-127"/>
+                          <a:cs typeface="+mn-cs"/>
+                        </a:rPr>
+                        <a:t/>
+                      </a:r>
+                      <a:endParaRPr lang="ko-KR" altLang="en-US" sz="900" b="0" i="0" u="none" strike="noStrike" kern="1200" dirty="0">
+                        <a:solidFill>
+                          <a:srgbClr val="0000FF"/>
+                        </a:solidFill>
+                        <a:effectLst/>
+                        <a:latin typeface="Microsoft GothicNeo" panose="020B0500000101010101" pitchFamily="50" charset="-127"/>
+                        <a:ea typeface="Microsoft GothicNeo" panose="020B0500000101010101" pitchFamily="50" charset="-127"/>
+                        <a:cs typeface="+mn-cs"/>
+                      </a:endParaRPr>
+                    </a:p>
+                  </a:txBody>
+                  <a:tcPr marL="5721" marR="5721" marT="5721" marB="0" anchor="ctr"/>
+                </a:tc>
+                <a:tc>
+                  <a:txBody>
+                    <a:bodyPr/>
+                    <a:lstStyle/>
+                    <a:p>
+                      <a:pPr algn="ctr" fontAlgn="ctr">
+                        <a:buNone/>
+                      </a:pPr>
+                      <a:r>
+                        <a:rPr lang="ko-KR" altLang="en-US" sz="900" b="0" i="0" u="none" strike="noStrike" kern="1200" dirty="0">
+                          <a:solidFill>
+                            <a:srgbClr val="0000FF"/>
+                          </a:solidFill>
+                          <a:effectLst/>
+                          <a:latin typeface="Microsoft GothicNeo" panose="020B0500000101010101" pitchFamily="50" charset="-127"/>
+                          <a:ea typeface="Microsoft GothicNeo" panose="020B0500000101010101" pitchFamily="50" charset="-127"/>
+                          <a:cs typeface="+mn-cs"/>
+                        </a:rPr>
+                        <a:t/>
+                      </a:r>
+                      <a:endParaRPr lang="en-US" altLang="ko-KR" sz="900" b="0" i="0" u="none" strike="noStrike" kern="1200" dirty="0">
+                        <a:solidFill>
+                          <a:srgbClr val="0000FF"/>
+                        </a:solidFill>
+                        <a:effectLst/>
+                        <a:latin typeface="Microsoft GothicNeo" panose="020B0500000101010101" pitchFamily="50" charset="-127"/>
+                        <a:ea typeface="Microsoft GothicNeo" panose="020B0500000101010101" pitchFamily="50" charset="-127"/>
+                        <a:cs typeface="+mn-cs"/>
+                      </a:endParaRPr>
+                    </a:p>
+                  </a:txBody>
+                  <a:tcPr marL="5721" marR="5721" marT="5721" marB="0" anchor="ctr"/>
+                </a:tc>
+                <a:tc>
+                  <a:txBody>
+                    <a:bodyPr/>
+                    <a:lstStyle/>
+                    <a:p>
+                      <a:pPr algn="r" fontAlgn="ctr">
+                        <a:buNone/>
+                      </a:pPr>
+                      <a:r>
+                        <a:rPr lang="ko-KR" altLang="en-US" sz="900" b="0" i="0" u="none" strike="noStrike" kern="1200" dirty="0">
+                          <a:solidFill>
+                            <a:srgbClr val="0000FF"/>
+                          </a:solidFill>
+                          <a:effectLst/>
+                          <a:latin typeface="Microsoft GothicNeo" panose="020B0500000101010101" pitchFamily="50" charset="-127"/>
+                          <a:ea typeface="Microsoft GothicNeo" panose="020B0500000101010101" pitchFamily="50" charset="-127"/>
+                          <a:cs typeface="+mn-cs"/>
+                        </a:rPr>
+                        <a:t/>
+                      </a:r>
+                      <a:endParaRPr lang="en-US" altLang="ko-KR" sz="900" b="0" i="0" u="none" strike="noStrike" kern="1200" dirty="0">
+                        <a:solidFill>
+                          <a:srgbClr val="0000FF"/>
+                        </a:solidFill>
+                        <a:effectLst/>
+                        <a:latin typeface="Microsoft GothicNeo" panose="020B0500000101010101" pitchFamily="50" charset="-127"/>
+                        <a:ea typeface="Microsoft GothicNeo" panose="020B0500000101010101" pitchFamily="50" charset="-127"/>
+                        <a:cs typeface="+mn-cs"/>
+                      </a:endParaRPr>
+                    </a:p>
+                  </a:txBody>
+                  <a:tcPr marL="5721" marR="5721" marT="5721" marB="0" anchor="ctr"/>
+                </a:tc>
+                <a:extLst>
+                  <a:ext uri="{0D108BD9-81ED-4DB2-BD59-A6C34878D82A}">
+                    <a16:rowId xmlns:a16="http://schemas.microsoft.com/office/drawing/2014/main" val="3639418345"/>
+                  </a:ext>
+                </a:extLst>
+              </a:tr>
+              <a:tr h="330000">
+                <a:tc>
+                  <a:txBody>
+                    <a:bodyPr/>
+                    <a:lstStyle/>
+                    <a:p>
+                      <a:pPr algn="ctr" fontAlgn="ctr">
+                        <a:buNone/>
+                      </a:pPr>
+                      <a:r>
+                        <a:rPr lang="en-US" altLang="ko-KR" sz="900" b="0" i="0" u="none" strike="noStrike" kern="1200">
+                          <a:solidFill>
+                            <a:srgbClr val="000000"/>
+                          </a:solidFill>
+                          <a:effectLst/>
+                          <a:latin typeface="Microsoft GothicNeo" panose="020B0500000101010101" pitchFamily="50" charset="-127"/>
+                          <a:ea typeface="Microsoft GothicNeo" panose="020B0500000101010101" pitchFamily="50" charset="-127"/>
+                          <a:cs typeface="+mn-cs"/>
+                        </a:rPr>
+                        <a:t>15</a:t>
+                      </a:r>
+                    </a:p>
+                  </a:txBody>
+                  <a:tcPr marL="5721" marR="5721" marT="5721" marB="0" anchor="ctr"/>
+                </a:tc>
+                <a:tc>
+                  <a:txBody>
+                    <a:bodyPr/>
+                    <a:lstStyle/>
+                    <a:p>
+                      <a:pPr algn="ctr" fontAlgn="ctr">
+                        <a:buNone/>
+                      </a:pPr>
+                      <a:r>
+                        <a:rPr lang="ko-KR" altLang="en-US" sz="900" b="0" i="0" u="none" strike="noStrike" kern="1200" dirty="0">
+                          <a:solidFill>
+                            <a:srgbClr val="000000"/>
+                          </a:solidFill>
+                          <a:effectLst/>
+                          <a:latin typeface="Microsoft GothicNeo" panose="020B0500000101010101" pitchFamily="50" charset="-127"/>
+                          <a:ea typeface="Microsoft GothicNeo" panose="020B0500000101010101" pitchFamily="50" charset="-127"/>
+                          <a:cs typeface="+mn-cs"/>
+                        </a:rPr>
+                        <a:t/>
+                      </a:r>
+                    </a:p>
+                  </a:txBody>
+                  <a:tcPr marL="5721" marR="5721" marT="5721" marB="0" anchor="ctr"/>
+                </a:tc>
+                <a:tc>
+                  <a:txBody>
+                    <a:bodyPr/>
+                    <a:lstStyle/>
+                    <a:p>
+                      <a:pPr algn="ctr" fontAlgn="ctr">
+                        <a:buNone/>
+                      </a:pPr>
+                      <a:r>
+                        <a:rPr lang="en-US" altLang="ko-KR" sz="900" b="0" i="0" u="none" strike="noStrike" kern="1200" dirty="0">
+                          <a:solidFill>
+                            <a:srgbClr val="0000FF"/>
+                          </a:solidFill>
+                          <a:effectLst/>
+                          <a:latin typeface="Microsoft GothicNeo" panose="020B0500000101010101" pitchFamily="50" charset="-127"/>
+                          <a:ea typeface="Microsoft GothicNeo" panose="020B0500000101010101" pitchFamily="50" charset="-127"/>
+                          <a:cs typeface="+mn-cs"/>
+                        </a:rPr>
+                        <a:t/>
+                      </a:r>
+                      <a:endParaRPr lang="ko-KR" altLang="en-US" sz="900" b="0" i="0" u="none" strike="noStrike" kern="1200" dirty="0">
+                        <a:solidFill>
+                          <a:srgbClr val="0000FF"/>
+                        </a:solidFill>
+                        <a:effectLst/>
+                        <a:latin typeface="Microsoft GothicNeo" panose="020B0500000101010101" pitchFamily="50" charset="-127"/>
+                        <a:ea typeface="Microsoft GothicNeo" panose="020B0500000101010101" pitchFamily="50" charset="-127"/>
+                        <a:cs typeface="+mn-cs"/>
+                      </a:endParaRPr>
+                    </a:p>
+                  </a:txBody>
+                  <a:tcPr marL="5721" marR="5721" marT="5721" marB="0" anchor="ctr"/>
+                </a:tc>
+                <a:tc>
+                  <a:txBody>
+                    <a:bodyPr/>
+                    <a:lstStyle/>
+                    <a:p>
+                      <a:pPr algn="ctr" fontAlgn="ctr">
+                        <a:buNone/>
+                      </a:pPr>
+                      <a:r>
+                        <a:rPr lang="ko-KR" altLang="en-US" sz="900" b="0" i="0" u="none" strike="noStrike" kern="1200" dirty="0">
+                          <a:solidFill>
+                            <a:srgbClr val="0000FF"/>
+                          </a:solidFill>
+                          <a:effectLst/>
+                          <a:latin typeface="Microsoft GothicNeo" panose="020B0500000101010101" pitchFamily="50" charset="-127"/>
+                          <a:ea typeface="Microsoft GothicNeo" panose="020B0500000101010101" pitchFamily="50" charset="-127"/>
+                          <a:cs typeface="+mn-cs"/>
+                        </a:rPr>
+                        <a:t/>
+                      </a:r>
+                      <a:endParaRPr lang="en-US" altLang="ko-KR" sz="900" b="0" i="0" u="none" strike="noStrike" kern="1200" dirty="0">
+                        <a:solidFill>
+                          <a:srgbClr val="0000FF"/>
+                        </a:solidFill>
+                        <a:effectLst/>
+                        <a:latin typeface="Microsoft GothicNeo" panose="020B0500000101010101" pitchFamily="50" charset="-127"/>
+                        <a:ea typeface="Microsoft GothicNeo" panose="020B0500000101010101" pitchFamily="50" charset="-127"/>
+                        <a:cs typeface="+mn-cs"/>
+                      </a:endParaRPr>
+                    </a:p>
+                  </a:txBody>
+                  <a:tcPr marL="5721" marR="5721" marT="5721" marB="0" anchor="ctr"/>
+                </a:tc>
+                <a:tc>
+                  <a:txBody>
+                    <a:bodyPr/>
+                    <a:lstStyle/>
+                    <a:p>
+                      <a:pPr algn="r" fontAlgn="ctr">
+                        <a:buNone/>
+                      </a:pPr>
+                      <a:r>
+                        <a:rPr lang="ko-KR" altLang="en-US" sz="900" b="0" i="0" u="none" strike="noStrike" kern="1200" dirty="0">
+                          <a:solidFill>
+                            <a:srgbClr val="0000FF"/>
+                          </a:solidFill>
+                          <a:effectLst/>
+                          <a:latin typeface="Microsoft GothicNeo" panose="020B0500000101010101" pitchFamily="50" charset="-127"/>
+                          <a:ea typeface="Microsoft GothicNeo" panose="020B0500000101010101" pitchFamily="50" charset="-127"/>
+                          <a:cs typeface="+mn-cs"/>
+                        </a:rPr>
+                        <a:t/>
+                      </a:r>
+                      <a:endParaRPr lang="en-US" altLang="ko-KR" sz="900" b="0" i="0" u="none" strike="noStrike" kern="1200" dirty="0">
+                        <a:solidFill>
+                          <a:srgbClr val="0000FF"/>
+                        </a:solidFill>
+                        <a:effectLst/>
+                        <a:latin typeface="Microsoft GothicNeo" panose="020B0500000101010101" pitchFamily="50" charset="-127"/>
+                        <a:ea typeface="Microsoft GothicNeo" panose="020B0500000101010101" pitchFamily="50" charset="-127"/>
+                        <a:cs typeface="+mn-cs"/>
+                      </a:endParaRPr>
+                    </a:p>
+                  </a:txBody>
+                  <a:tcPr marL="5721" marR="5721" marT="5721" marB="0" anchor="ctr"/>
+                </a:tc>
+                <a:extLst>
+                  <a:ext uri="{0D108BD9-81ED-4DB2-BD59-A6C34878D82A}">
+                    <a16:rowId xmlns:a16="http://schemas.microsoft.com/office/drawing/2014/main" val="3639418345"/>
                   </a:ext>
                 </a:extLst>
               </a:tr>
@@ -13347,7 +15195,7 @@
                           <a:ea typeface="Microsoft GothicNeo" panose="020B0500000101010101" pitchFamily="50" charset="-127"/>
                           <a:cs typeface="+mn-cs"/>
                         </a:rPr>
-                        <a:t>직접성 경비 총 금액 기입</a:t>
+                        <a:t/>
                       </a:r>
                       <a:endParaRPr lang="en-US" altLang="ko-KR" sz="900" b="0" i="0" u="none" strike="noStrike" kern="1200" dirty="0">
                         <a:solidFill>
@@ -13425,7 +15273,7 @@
         </p:nvSpPr>
         <p:spPr>
           <a:xfrm>
-            <a:off x="465138" y="3652077"/>
+            <a:off x="465138" y="7494315"/>
             <a:ext cx="5810043" cy="307777"/>
           </a:xfrm>
           <a:prstGeom prst="rect">
@@ -13464,7 +15312,7 @@
         <p:nvSpPr>
           <p:cNvPr id="2" name="직사각형 1">
             <a:extLst>
-              <a:ext uri="{FF2B5EF4-FFF2-40B4-BE49-F238E27FC236}">
+              <a:ext uri="{FF2B5EF4-FFF2-40B4-BE49-F238E27FC236}" cy="1200000">
                 <a16:creationId xmlns:a16="http://schemas.microsoft.com/office/drawing/2014/main" id="{36A36E19-1144-ED82-6262-4078AFB9FBBE}"/>
               </a:ext>
             </a:extLst>
@@ -13474,7 +15322,7 @@
         </p:nvSpPr>
         <p:spPr>
           <a:xfrm>
-            <a:off x="395266" y="4500449"/>
+            <a:off x="395266" y="8350000"/>
             <a:ext cx="6260659" cy="1630062"/>
           </a:xfrm>
           <a:prstGeom prst="rect">
@@ -13487,239 +15335,37 @@
           </a:bodyPr>
           <a:lstStyle/>
           <a:p>
-            <a:pPr>
-              <a:lnSpc>
-                <a:spcPct val="150000"/>
-              </a:lnSpc>
-              <a:defRPr/>
-            </a:pPr>
-            <a:r>
-              <a:rPr lang="en-US" altLang="ko-KR" sz="1600" dirty="0">
-                <a:solidFill>
-                  <a:srgbClr val="0000FF"/>
-                </a:solidFill>
-                <a:latin typeface="+mn-ea"/>
-              </a:rPr>
-              <a:t>*</a:t>
-            </a:r>
-            <a:r>
-              <a:rPr lang="ko-KR" altLang="en-US" sz="1600" dirty="0">
-                <a:solidFill>
-                  <a:srgbClr val="0000FF"/>
-                </a:solidFill>
-                <a:latin typeface="+mn-ea"/>
-              </a:rPr>
-              <a:t>파란색 글씨는 최종 제출시 모두 삭제하여 제출 부탁드립니다</a:t>
-            </a:r>
-            <a:r>
-              <a:rPr lang="en-US" altLang="ko-KR" sz="1600" dirty="0">
-                <a:solidFill>
-                  <a:srgbClr val="0000FF"/>
-                </a:solidFill>
-                <a:latin typeface="+mn-ea"/>
-              </a:rPr>
-              <a:t>.</a:t>
+            <a:r>
+              <a:rPr sz="800">
+                <a:solidFill>
+                  <a:srgbClr val="0000FF"/>
+                </a:solidFill>
+                <a:ea typeface="맑은 고딕"/>
+              </a:rPr>
+              <a:t>* 파란색 글씨는 최종 제출 시 모두 삭제하여 제출 부탁드립니다.</a:t>
             </a:r>
           </a:p>
           <a:p>
-            <a:pPr>
-              <a:lnSpc>
-                <a:spcPct val="150000"/>
-              </a:lnSpc>
-              <a:defRPr/>
-            </a:pPr>
-            <a:r>
-              <a:rPr lang="en-US" altLang="ko-KR" sz="1600" dirty="0">
-                <a:solidFill>
-                  <a:srgbClr val="0000FF"/>
-                </a:solidFill>
-                <a:latin typeface="+mn-ea"/>
-              </a:rPr>
-              <a:t>[</a:t>
-            </a:r>
-            <a:r>
-              <a:rPr lang="ko-KR" altLang="en-US" sz="1600" dirty="0">
-                <a:solidFill>
-                  <a:srgbClr val="0000FF"/>
-                </a:solidFill>
-                <a:latin typeface="+mn-ea"/>
-              </a:rPr>
-              <a:t>연수 운영비</a:t>
-            </a:r>
-            <a:r>
-              <a:rPr lang="en-US" altLang="ko-KR" sz="1600" dirty="0">
-                <a:solidFill>
-                  <a:srgbClr val="0000FF"/>
-                </a:solidFill>
-                <a:latin typeface="+mn-ea"/>
-              </a:rPr>
-              <a:t>]</a:t>
+            <a:r>
+              <a:rPr sz="800">
+                <a:solidFill>
+                  <a:srgbClr val="0000FF"/>
+                </a:solidFill>
+                <a:ea typeface="맑은 고딕"/>
+              </a:rPr>
+              <a:t>[직접성 경비] 주의사항: 노트북·태블릿 등 자산취득성 물품 구입 금지, AI 구독료는 동아리 활동 기간 내 내역만 인정</a:t>
             </a:r>
           </a:p>
           <a:p>
-            <a:pPr marL="342900" indent="-342900">
-              <a:lnSpc>
-                <a:spcPct val="150000"/>
-              </a:lnSpc>
-              <a:buFont typeface="+mj-lt"/>
-              <a:buAutoNum type="arabicPeriod"/>
-            </a:pPr>
-            <a:r>
-              <a:rPr lang="ko-KR" altLang="en-US" sz="1200" b="1" dirty="0">
-                <a:solidFill>
-                  <a:srgbClr val="0000FF"/>
-                </a:solidFill>
-                <a:latin typeface="+mn-ea"/>
-              </a:rPr>
-              <a:t>주의사항</a:t>
-            </a:r>
-            <a:r>
-              <a:rPr lang="en-US" altLang="ko-KR" sz="1200" b="1" dirty="0">
-                <a:solidFill>
-                  <a:srgbClr val="0000FF"/>
-                </a:solidFill>
-                <a:latin typeface="+mn-ea"/>
-              </a:rPr>
-              <a:t>: </a:t>
-            </a:r>
-            <a:r>
-              <a:rPr lang="ko-KR" altLang="en-US" sz="1200" b="1" dirty="0">
-                <a:solidFill>
-                  <a:srgbClr val="0000FF"/>
-                </a:solidFill>
-                <a:latin typeface="+mn-ea"/>
-              </a:rPr>
-              <a:t>노트북</a:t>
-            </a:r>
-            <a:r>
-              <a:rPr lang="en-US" altLang="ko-KR" sz="1200" b="1" dirty="0">
-                <a:solidFill>
-                  <a:srgbClr val="0000FF"/>
-                </a:solidFill>
-                <a:latin typeface="+mn-ea"/>
-              </a:rPr>
-              <a:t>·</a:t>
-            </a:r>
-            <a:r>
-              <a:rPr lang="ko-KR" altLang="en-US" sz="1200" b="1" dirty="0">
-                <a:solidFill>
-                  <a:srgbClr val="0000FF"/>
-                </a:solidFill>
-                <a:latin typeface="+mn-ea"/>
-              </a:rPr>
-              <a:t>태블릿 등 자산취득성 물품 구입 금지</a:t>
-            </a:r>
-            <a:r>
-              <a:rPr lang="en-US" altLang="ko-KR" sz="1200" b="1" dirty="0">
-                <a:solidFill>
-                  <a:srgbClr val="0000FF"/>
-                </a:solidFill>
-                <a:latin typeface="+mn-ea"/>
-              </a:rPr>
-              <a:t>, AI </a:t>
-            </a:r>
-            <a:r>
-              <a:rPr lang="ko-KR" altLang="en-US" sz="1200" b="1" dirty="0">
-                <a:solidFill>
-                  <a:srgbClr val="0000FF"/>
-                </a:solidFill>
-                <a:latin typeface="+mn-ea"/>
-              </a:rPr>
-              <a:t>구독료는 동아리 활동 기간 내 내역만 인정  </a:t>
-            </a:r>
-            <a:endParaRPr lang="en-US" altLang="ko-KR" sz="1200" b="1" dirty="0">
-              <a:solidFill>
-                <a:srgbClr val="0000FF"/>
-              </a:solidFill>
-              <a:latin typeface="+mn-ea"/>
-            </a:endParaRPr>
-          </a:p>
-          <a:p>
-            <a:pPr marL="342900" indent="-342900">
-              <a:lnSpc>
-                <a:spcPct val="150000"/>
-              </a:lnSpc>
-              <a:buFont typeface="+mj-lt"/>
-              <a:buAutoNum type="arabicPeriod"/>
-            </a:pPr>
-            <a:r>
-              <a:rPr lang="ko-KR" altLang="en-US" sz="1200" b="1" dirty="0" err="1">
-                <a:solidFill>
-                  <a:srgbClr val="0000FF"/>
-                </a:solidFill>
-                <a:latin typeface="+mn-ea"/>
-              </a:rPr>
-              <a:t>필수증빙</a:t>
-            </a:r>
-            <a:r>
-              <a:rPr lang="en-US" altLang="ko-KR" sz="1200" b="1" dirty="0">
-                <a:solidFill>
-                  <a:srgbClr val="0000FF"/>
-                </a:solidFill>
-                <a:latin typeface="+mn-ea"/>
-              </a:rPr>
-              <a:t>: </a:t>
-            </a:r>
-            <a:r>
-              <a:rPr lang="ko-KR" altLang="en-US" sz="1200" b="1" dirty="0">
-                <a:solidFill>
-                  <a:srgbClr val="0000FF"/>
-                </a:solidFill>
-                <a:latin typeface="+mn-ea"/>
-              </a:rPr>
-              <a:t>구매 내역서</a:t>
-            </a:r>
-            <a:r>
-              <a:rPr lang="en-US" altLang="ko-KR" sz="1200" b="1" dirty="0">
-                <a:solidFill>
-                  <a:srgbClr val="0000FF"/>
-                </a:solidFill>
-                <a:latin typeface="+mn-ea"/>
-              </a:rPr>
-              <a:t>, </a:t>
-            </a:r>
-            <a:r>
-              <a:rPr lang="ko-KR" altLang="en-US" sz="1200" b="1" dirty="0">
-                <a:solidFill>
-                  <a:srgbClr val="0000FF"/>
-                </a:solidFill>
-                <a:latin typeface="+mn-ea"/>
-              </a:rPr>
-              <a:t>신용카드 영수증 </a:t>
-            </a:r>
-            <a:r>
-              <a:rPr lang="en-US" altLang="ko-KR" sz="1200" b="1" dirty="0">
-                <a:solidFill>
-                  <a:srgbClr val="0000FF"/>
-                </a:solidFill>
-                <a:latin typeface="+mn-ea"/>
-              </a:rPr>
-              <a:t>(</a:t>
-            </a:r>
-            <a:r>
-              <a:rPr lang="ko-KR" altLang="en-US" sz="1200" b="1" dirty="0">
-                <a:solidFill>
-                  <a:srgbClr val="0000FF"/>
-                </a:solidFill>
-                <a:latin typeface="+mn-ea"/>
-              </a:rPr>
-              <a:t>해외 결제 시 국내 카드사 원화 결제금액  함께 첨부</a:t>
-            </a:r>
-            <a:r>
-              <a:rPr lang="en-US" altLang="ko-KR" sz="1200" b="1" dirty="0">
-                <a:solidFill>
-                  <a:srgbClr val="0000FF"/>
-                </a:solidFill>
-                <a:latin typeface="+mn-ea"/>
-              </a:rPr>
-              <a:t>) </a:t>
-            </a:r>
-            <a:endParaRPr lang="en-US" altLang="ko-KR" sz="1600" dirty="0">
-              <a:solidFill>
-                <a:srgbClr val="0000FF"/>
-              </a:solidFill>
-              <a:latin typeface="+mn-ea"/>
-            </a:endParaRPr>
+            <a:r>
+              <a:rPr sz="800">
+                <a:solidFill>
+                  <a:srgbClr val="0000FF"/>
+                </a:solidFill>
+                <a:ea typeface="맑은 고딕"/>
+              </a:rPr>
+              <a:t>필수증빙: 구매 내역서, 신용카드 영수증 (해외 결제 시 국내 카드사 원화 결제금액 함께 첨부)</a:t>
+            </a:r>
           </a:p>
         </p:txBody>
       </p:sp>

</xml_diff>